<commit_message>
feat(ui): 100% mobile-responsive flexbox telemetry, adaptive grid cards, and executive PPT update
</commit_message>
<xml_diff>
--- a/presentation_10_slides_executive.pptx
+++ b/presentation_10_slides_executive.pptx
@@ -2,21 +2,21 @@
 <file path=ppt/presentation.xml><?xml version="1.0" encoding="utf-8"?>
 <p:presentation xmlns:a="http://schemas.openxmlformats.org/drawingml/2006/main" xmlns:r="http://schemas.openxmlformats.org/officeDocument/2006/relationships" xmlns:p="http://schemas.openxmlformats.org/presentationml/2006/main" saveSubsetFonts="1" autoCompressPictures="0">
   <p:sldMasterIdLst>
-    <p:sldMasterId id="2147483648" r:id="rId1"/>
+    <p:sldMasterId id="2147483780" r:id="rId1"/>
   </p:sldMasterIdLst>
   <p:sldIdLst>
-    <p:sldId id="256" r:id="rId7"/>
-    <p:sldId id="257" r:id="rId8"/>
-    <p:sldId id="258" r:id="rId9"/>
-    <p:sldId id="259" r:id="rId10"/>
-    <p:sldId id="260" r:id="rId11"/>
-    <p:sldId id="261" r:id="rId12"/>
-    <p:sldId id="262" r:id="rId13"/>
-    <p:sldId id="263" r:id="rId14"/>
-    <p:sldId id="264" r:id="rId15"/>
-    <p:sldId id="265" r:id="rId16"/>
+    <p:sldId id="256" r:id="rId2"/>
+    <p:sldId id="257" r:id="rId3"/>
+    <p:sldId id="258" r:id="rId4"/>
+    <p:sldId id="259" r:id="rId5"/>
+    <p:sldId id="260" r:id="rId6"/>
+    <p:sldId id="261" r:id="rId7"/>
+    <p:sldId id="262" r:id="rId8"/>
+    <p:sldId id="263" r:id="rId9"/>
+    <p:sldId id="264" r:id="rId10"/>
+    <p:sldId id="265" r:id="rId11"/>
   </p:sldIdLst>
-  <p:sldSz cx="12191695" cy="6858000" type="screen4x3"/>
+  <p:sldSz cx="12192000" cy="6858000"/>
   <p:notesSz cx="6858000" cy="9144000"/>
   <p:defaultTextStyle>
     <a:defPPr>
@@ -145,8 +145,8 @@
         </p:nvSpPr>
         <p:spPr>
           <a:xfrm>
-            <a:off x="685800" y="2130425"/>
-            <a:ext cx="7772400" cy="1470025"/>
+            <a:off x="1828800" y="1859280"/>
+            <a:ext cx="8534400" cy="1295400"/>
           </a:xfrm>
         </p:spPr>
         <p:txBody>
@@ -157,30 +157,76 @@
               <a:rPr lang="en-US" smtClean="0"/>
               <a:t>Click to edit Master title style</a:t>
             </a:r>
-            <a:endParaRPr lang="en-US"/>
-          </a:p>
-        </p:txBody>
-      </p:sp>
-      <p:sp>
-        <p:nvSpPr>
-          <p:cNvPr id="3" name="Subtitle 2"/>
-          <p:cNvSpPr>
-            <a:spLocks noGrp="1"/>
-          </p:cNvSpPr>
-          <p:nvPr>
-            <p:ph type="subTitle" idx="1"/>
-          </p:nvPr>
-        </p:nvSpPr>
+            <a:endParaRPr lang="en-US" dirty="0"/>
+          </a:p>
+        </p:txBody>
+      </p:sp>
+      <p:pic>
+        <p:nvPicPr>
+          <p:cNvPr id="8" name="Picture 7" descr="flourish2.png"/>
+          <p:cNvPicPr>
+            <a:picLocks noChangeAspect="1"/>
+          </p:cNvPicPr>
+          <p:nvPr/>
+        </p:nvPicPr>
+        <p:blipFill>
+          <a:blip r:embed="rId2">
+            <a:duotone>
+              <a:prstClr val="black"/>
+              <a:schemeClr val="tx2">
+                <a:tint val="45000"/>
+                <a:satMod val="400000"/>
+              </a:schemeClr>
+            </a:duotone>
+            <a:lum bright="-14000"/>
+          </a:blip>
+          <a:stretch>
+            <a:fillRect/>
+          </a:stretch>
+        </p:blipFill>
         <p:spPr>
           <a:xfrm>
-            <a:off x="1371600" y="3886200"/>
-            <a:ext cx="6400800" cy="1752600"/>
+            <a:off x="0" y="2801112"/>
+            <a:ext cx="12192000" cy="932688"/>
+          </a:xfrm>
+          <a:prstGeom prst="rect">
+            <a:avLst/>
+          </a:prstGeom>
+        </p:spPr>
+      </p:pic>
+      <p:sp>
+        <p:nvSpPr>
+          <p:cNvPr id="3" name="Subtitle 2"/>
+          <p:cNvSpPr>
+            <a:spLocks noGrp="1"/>
+          </p:cNvSpPr>
+          <p:nvPr>
+            <p:ph type="subTitle" idx="1"/>
+          </p:nvPr>
+        </p:nvSpPr>
+        <p:spPr>
+          <a:xfrm>
+            <a:off x="1828800" y="3429000"/>
+            <a:ext cx="8534400" cy="762000"/>
           </a:xfrm>
         </p:spPr>
         <p:txBody>
-          <a:bodyPr/>
+          <a:bodyPr>
+            <a:normAutofit/>
+          </a:bodyPr>
           <a:lstStyle>
             <a:lvl1pPr marL="0" indent="0" algn="ctr">
+              <a:buNone/>
+              <a:defRPr sz="2000" i="1" baseline="0">
+                <a:solidFill>
+                  <a:schemeClr val="tx1">
+                    <a:lumMod val="65000"/>
+                    <a:lumOff val="35000"/>
+                  </a:schemeClr>
+                </a:solidFill>
+              </a:defRPr>
+            </a:lvl1pPr>
+            <a:lvl2pPr marL="457200" indent="0" algn="ctr">
               <a:buNone/>
               <a:defRPr>
                 <a:solidFill>
@@ -189,8 +235,8 @@
                   </a:schemeClr>
                 </a:solidFill>
               </a:defRPr>
-            </a:lvl1pPr>
-            <a:lvl2pPr marL="457200" indent="0" algn="ctr">
+            </a:lvl2pPr>
+            <a:lvl3pPr marL="914400" indent="0" algn="ctr">
               <a:buNone/>
               <a:defRPr>
                 <a:solidFill>
@@ -199,8 +245,8 @@
                   </a:schemeClr>
                 </a:solidFill>
               </a:defRPr>
-            </a:lvl2pPr>
-            <a:lvl3pPr marL="914400" indent="0" algn="ctr">
+            </a:lvl3pPr>
+            <a:lvl4pPr marL="1371600" indent="0" algn="ctr">
               <a:buNone/>
               <a:defRPr>
                 <a:solidFill>
@@ -209,8 +255,8 @@
                   </a:schemeClr>
                 </a:solidFill>
               </a:defRPr>
-            </a:lvl3pPr>
-            <a:lvl4pPr marL="1371600" indent="0" algn="ctr">
+            </a:lvl4pPr>
+            <a:lvl5pPr marL="1828800" indent="0" algn="ctr">
               <a:buNone/>
               <a:defRPr>
                 <a:solidFill>
@@ -219,8 +265,8 @@
                   </a:schemeClr>
                 </a:solidFill>
               </a:defRPr>
-            </a:lvl4pPr>
-            <a:lvl5pPr marL="1828800" indent="0" algn="ctr">
+            </a:lvl5pPr>
+            <a:lvl6pPr marL="2286000" indent="0" algn="ctr">
               <a:buNone/>
               <a:defRPr>
                 <a:solidFill>
@@ -229,8 +275,8 @@
                   </a:schemeClr>
                 </a:solidFill>
               </a:defRPr>
-            </a:lvl5pPr>
-            <a:lvl6pPr marL="2286000" indent="0" algn="ctr">
+            </a:lvl6pPr>
+            <a:lvl7pPr marL="2743200" indent="0" algn="ctr">
               <a:buNone/>
               <a:defRPr>
                 <a:solidFill>
@@ -239,8 +285,8 @@
                   </a:schemeClr>
                 </a:solidFill>
               </a:defRPr>
-            </a:lvl6pPr>
-            <a:lvl7pPr marL="2743200" indent="0" algn="ctr">
+            </a:lvl7pPr>
+            <a:lvl8pPr marL="3200400" indent="0" algn="ctr">
               <a:buNone/>
               <a:defRPr>
                 <a:solidFill>
@@ -249,8 +295,8 @@
                   </a:schemeClr>
                 </a:solidFill>
               </a:defRPr>
-            </a:lvl7pPr>
-            <a:lvl8pPr marL="3200400" indent="0" algn="ctr">
+            </a:lvl8pPr>
+            <a:lvl9pPr marL="3657600" indent="0" algn="ctr">
               <a:buNone/>
               <a:defRPr>
                 <a:solidFill>
@@ -259,16 +305,6 @@
                   </a:schemeClr>
                 </a:solidFill>
               </a:defRPr>
-            </a:lvl8pPr>
-            <a:lvl9pPr marL="3657600" indent="0" algn="ctr">
-              <a:buNone/>
-              <a:defRPr>
-                <a:solidFill>
-                  <a:schemeClr val="tx1">
-                    <a:tint val="75000"/>
-                  </a:schemeClr>
-                </a:solidFill>
-              </a:defRPr>
             </a:lvl9pPr>
           </a:lstStyle>
           <a:p>
@@ -276,7 +312,7 @@
               <a:rPr lang="en-US" smtClean="0"/>
               <a:t>Click to edit Master subtitle style</a:t>
             </a:r>
-            <a:endParaRPr lang="en-US"/>
+            <a:endParaRPr lang="en-US" dirty="0"/>
           </a:p>
         </p:txBody>
       </p:sp>
@@ -290,14 +326,14 @@
             <p:ph type="dt" sz="half" idx="10"/>
           </p:nvPr>
         </p:nvSpPr>
-        <p:spPr/>
+        <p:spPr bwMode="white"/>
         <p:txBody>
           <a:bodyPr/>
           <a:lstStyle/>
           <a:p>
             <a:fld id="{5BCAD085-E8A6-8845-BD4E-CB4CCA059FC4}" type="datetimeFigureOut">
               <a:rPr lang="en-US" smtClean="0"/>
-              <a:t>1/27/13</a:t>
+              <a:t>9/18/2026</a:t>
             </a:fld>
             <a:endParaRPr lang="en-US"/>
           </a:p>
@@ -313,7 +349,7 @@
             <p:ph type="ftr" sz="quarter" idx="11"/>
           </p:nvPr>
         </p:nvSpPr>
-        <p:spPr/>
+        <p:spPr bwMode="white"/>
         <p:txBody>
           <a:bodyPr/>
           <a:lstStyle/>
@@ -346,11 +382,6 @@
         </p:txBody>
       </p:sp>
     </p:spTree>
-    <p:extLst>
-      <p:ext uri="{BB962C8B-B14F-4D97-AF65-F5344CB8AC3E}">
-        <p14:creationId xmlns:p14="http://schemas.microsoft.com/office/powerpoint/2010/main" val="3168075583"/>
-      </p:ext>
-    </p:extLst>
   </p:cSld>
   <p:clrMapOvr>
     <a:masterClrMapping/>
@@ -467,7 +498,7 @@
           <a:p>
             <a:fld id="{5BCAD085-E8A6-8845-BD4E-CB4CCA059FC4}" type="datetimeFigureOut">
               <a:rPr lang="en-US" smtClean="0"/>
-              <a:t>1/27/13</a:t>
+              <a:t>9/18/2026</a:t>
             </a:fld>
             <a:endParaRPr lang="en-US"/>
           </a:p>
@@ -516,11 +547,6 @@
         </p:txBody>
       </p:sp>
     </p:spTree>
-    <p:extLst>
-      <p:ext uri="{BB962C8B-B14F-4D97-AF65-F5344CB8AC3E}">
-        <p14:creationId xmlns:p14="http://schemas.microsoft.com/office/powerpoint/2010/main" val="2910927964"/>
-      </p:ext>
-    </p:extLst>
   </p:cSld>
   <p:clrMapOvr>
     <a:masterClrMapping/>
@@ -557,8 +583,8 @@
         </p:nvSpPr>
         <p:spPr>
           <a:xfrm>
-            <a:off x="6629400" y="274638"/>
-            <a:ext cx="2057400" cy="5851525"/>
+            <a:off x="8839200" y="1209041"/>
+            <a:ext cx="1727200" cy="4318000"/>
           </a:xfrm>
         </p:spPr>
         <p:txBody>
@@ -569,7 +595,7 @@
               <a:rPr lang="en-US" smtClean="0"/>
               <a:t>Click to edit Master title style</a:t>
             </a:r>
-            <a:endParaRPr lang="en-US"/>
+            <a:endParaRPr lang="en-US" dirty="0"/>
           </a:p>
         </p:txBody>
       </p:sp>
@@ -585,8 +611,8 @@
         </p:nvSpPr>
         <p:spPr>
           <a:xfrm>
-            <a:off x="457200" y="274638"/>
-            <a:ext cx="6019800" cy="5851525"/>
+            <a:off x="1727200" y="1219200"/>
+            <a:ext cx="6908800" cy="4267201"/>
           </a:xfrm>
         </p:spPr>
         <p:txBody>
@@ -626,7 +652,7 @@
               <a:rPr lang="en-US" smtClean="0"/>
               <a:t>Fifth level</a:t>
             </a:r>
-            <a:endParaRPr lang="en-US"/>
+            <a:endParaRPr lang="en-US" dirty="0"/>
           </a:p>
         </p:txBody>
       </p:sp>
@@ -647,7 +673,7 @@
           <a:p>
             <a:fld id="{5BCAD085-E8A6-8845-BD4E-CB4CCA059FC4}" type="datetimeFigureOut">
               <a:rPr lang="en-US" smtClean="0"/>
-              <a:t>1/27/13</a:t>
+              <a:t>9/18/2026</a:t>
             </a:fld>
             <a:endParaRPr lang="en-US"/>
           </a:p>
@@ -696,11 +722,6 @@
         </p:txBody>
       </p:sp>
     </p:spTree>
-    <p:extLst>
-      <p:ext uri="{BB962C8B-B14F-4D97-AF65-F5344CB8AC3E}">
-        <p14:creationId xmlns:p14="http://schemas.microsoft.com/office/powerpoint/2010/main" val="3612223792"/>
-      </p:ext>
-    </p:extLst>
   </p:cSld>
   <p:clrMapOvr>
     <a:masterClrMapping/>
@@ -744,7 +765,7 @@
               <a:rPr lang="en-US" smtClean="0"/>
               <a:t>Click to edit Master title style</a:t>
             </a:r>
-            <a:endParaRPr lang="en-US"/>
+            <a:endParaRPr lang="en-US" dirty="0"/>
           </a:p>
         </p:txBody>
       </p:sp>
@@ -758,66 +779,71 @@
             <p:ph idx="1"/>
           </p:nvPr>
         </p:nvSpPr>
+        <p:spPr>
+          <a:xfrm>
+            <a:off x="1828800" y="2438401"/>
+            <a:ext cx="8534400" cy="3048001"/>
+          </a:xfrm>
+        </p:spPr>
+        <p:txBody>
+          <a:bodyPr/>
+          <a:lstStyle/>
+          <a:p>
+            <a:pPr lvl="0"/>
+            <a:r>
+              <a:rPr lang="en-US" smtClean="0"/>
+              <a:t>Click to edit Master text styles</a:t>
+            </a:r>
+          </a:p>
+          <a:p>
+            <a:pPr lvl="1"/>
+            <a:r>
+              <a:rPr lang="en-US" smtClean="0"/>
+              <a:t>Second level</a:t>
+            </a:r>
+          </a:p>
+          <a:p>
+            <a:pPr lvl="2"/>
+            <a:r>
+              <a:rPr lang="en-US" smtClean="0"/>
+              <a:t>Third level</a:t>
+            </a:r>
+          </a:p>
+          <a:p>
+            <a:pPr lvl="3"/>
+            <a:r>
+              <a:rPr lang="en-US" smtClean="0"/>
+              <a:t>Fourth level</a:t>
+            </a:r>
+          </a:p>
+          <a:p>
+            <a:pPr lvl="4"/>
+            <a:r>
+              <a:rPr lang="en-US" smtClean="0"/>
+              <a:t>Fifth level</a:t>
+            </a:r>
+            <a:endParaRPr lang="en-US" dirty="0"/>
+          </a:p>
+        </p:txBody>
+      </p:sp>
+      <p:sp>
+        <p:nvSpPr>
+          <p:cNvPr id="4" name="Date Placeholder 3"/>
+          <p:cNvSpPr>
+            <a:spLocks noGrp="1"/>
+          </p:cNvSpPr>
+          <p:nvPr>
+            <p:ph type="dt" sz="half" idx="10"/>
+          </p:nvPr>
+        </p:nvSpPr>
         <p:spPr/>
         <p:txBody>
           <a:bodyPr/>
           <a:lstStyle/>
           <a:p>
-            <a:pPr lvl="0"/>
-            <a:r>
-              <a:rPr lang="en-US" smtClean="0"/>
-              <a:t>Click to edit Master text styles</a:t>
-            </a:r>
-          </a:p>
-          <a:p>
-            <a:pPr lvl="1"/>
-            <a:r>
-              <a:rPr lang="en-US" smtClean="0"/>
-              <a:t>Second level</a:t>
-            </a:r>
-          </a:p>
-          <a:p>
-            <a:pPr lvl="2"/>
-            <a:r>
-              <a:rPr lang="en-US" smtClean="0"/>
-              <a:t>Third level</a:t>
-            </a:r>
-          </a:p>
-          <a:p>
-            <a:pPr lvl="3"/>
-            <a:r>
-              <a:rPr lang="en-US" smtClean="0"/>
-              <a:t>Fourth level</a:t>
-            </a:r>
-          </a:p>
-          <a:p>
-            <a:pPr lvl="4"/>
-            <a:r>
-              <a:rPr lang="en-US" smtClean="0"/>
-              <a:t>Fifth level</a:t>
-            </a:r>
-            <a:endParaRPr lang="en-US"/>
-          </a:p>
-        </p:txBody>
-      </p:sp>
-      <p:sp>
-        <p:nvSpPr>
-          <p:cNvPr id="4" name="Date Placeholder 3"/>
-          <p:cNvSpPr>
-            <a:spLocks noGrp="1"/>
-          </p:cNvSpPr>
-          <p:nvPr>
-            <p:ph type="dt" sz="half" idx="10"/>
-          </p:nvPr>
-        </p:nvSpPr>
-        <p:spPr/>
-        <p:txBody>
-          <a:bodyPr/>
-          <a:lstStyle/>
-          <a:p>
             <a:fld id="{5BCAD085-E8A6-8845-BD4E-CB4CCA059FC4}" type="datetimeFigureOut">
               <a:rPr lang="en-US" smtClean="0"/>
-              <a:t>1/27/13</a:t>
+              <a:t>9/18/2026</a:t>
             </a:fld>
             <a:endParaRPr lang="en-US"/>
           </a:p>
@@ -865,12 +891,40 @@
           </a:p>
         </p:txBody>
       </p:sp>
+      <p:pic>
+        <p:nvPicPr>
+          <p:cNvPr id="9" name="Picture 8" descr="flourish2.png"/>
+          <p:cNvPicPr>
+            <a:picLocks noChangeAspect="1"/>
+          </p:cNvPicPr>
+          <p:nvPr/>
+        </p:nvPicPr>
+        <p:blipFill>
+          <a:blip r:embed="rId2">
+            <a:duotone>
+              <a:prstClr val="black"/>
+              <a:schemeClr val="tx2">
+                <a:tint val="45000"/>
+                <a:satMod val="400000"/>
+              </a:schemeClr>
+            </a:duotone>
+            <a:lum bright="-14000"/>
+          </a:blip>
+          <a:stretch>
+            <a:fillRect/>
+          </a:stretch>
+        </p:blipFill>
+        <p:spPr>
+          <a:xfrm>
+            <a:off x="0" y="1618488"/>
+            <a:ext cx="12192000" cy="932688"/>
+          </a:xfrm>
+          <a:prstGeom prst="rect">
+            <a:avLst/>
+          </a:prstGeom>
+        </p:spPr>
+      </p:pic>
     </p:spTree>
-    <p:extLst>
-      <p:ext uri="{BB962C8B-B14F-4D97-AF65-F5344CB8AC3E}">
-        <p14:creationId xmlns:p14="http://schemas.microsoft.com/office/powerpoint/2010/main" val="2614314258"/>
-      </p:ext>
-    </p:extLst>
   </p:cSld>
   <p:clrMapOvr>
     <a:masterClrMapping/>
@@ -897,25 +951,125 @@
       </p:grpSpPr>
       <p:sp>
         <p:nvSpPr>
-          <p:cNvPr id="2" name="Title 1"/>
-          <p:cNvSpPr>
-            <a:spLocks noGrp="1"/>
-          </p:cNvSpPr>
-          <p:nvPr>
-            <p:ph type="title"/>
-          </p:nvPr>
-        </p:nvSpPr>
+          <p:cNvPr id="4" name="Date Placeholder 3"/>
+          <p:cNvSpPr>
+            <a:spLocks noGrp="1"/>
+          </p:cNvSpPr>
+          <p:nvPr>
+            <p:ph type="dt" sz="half" idx="10"/>
+          </p:nvPr>
+        </p:nvSpPr>
+        <p:spPr/>
+        <p:txBody>
+          <a:bodyPr/>
+          <a:lstStyle/>
+          <a:p>
+            <a:fld id="{5BCAD085-E8A6-8845-BD4E-CB4CCA059FC4}" type="datetimeFigureOut">
+              <a:rPr lang="en-US" smtClean="0"/>
+              <a:t>9/18/2026</a:t>
+            </a:fld>
+            <a:endParaRPr lang="en-US"/>
+          </a:p>
+        </p:txBody>
+      </p:sp>
+      <p:sp>
+        <p:nvSpPr>
+          <p:cNvPr id="5" name="Footer Placeholder 4"/>
+          <p:cNvSpPr>
+            <a:spLocks noGrp="1"/>
+          </p:cNvSpPr>
+          <p:nvPr>
+            <p:ph type="ftr" sz="quarter" idx="11"/>
+          </p:nvPr>
+        </p:nvSpPr>
+        <p:spPr/>
+        <p:txBody>
+          <a:bodyPr/>
+          <a:lstStyle/>
+          <a:p>
+            <a:endParaRPr lang="en-US"/>
+          </a:p>
+        </p:txBody>
+      </p:sp>
+      <p:sp>
+        <p:nvSpPr>
+          <p:cNvPr id="6" name="Slide Number Placeholder 5"/>
+          <p:cNvSpPr>
+            <a:spLocks noGrp="1"/>
+          </p:cNvSpPr>
+          <p:nvPr>
+            <p:ph type="sldNum" sz="quarter" idx="12"/>
+          </p:nvPr>
+        </p:nvSpPr>
+        <p:spPr/>
+        <p:txBody>
+          <a:bodyPr/>
+          <a:lstStyle/>
+          <a:p>
+            <a:fld id="{C1FF6DA9-008F-8B48-92A6-B652298478BF}" type="slidenum">
+              <a:rPr lang="en-US" smtClean="0"/>
+              <a:t>‹#›</a:t>
+            </a:fld>
+            <a:endParaRPr lang="en-US"/>
+          </a:p>
+        </p:txBody>
+      </p:sp>
+      <p:pic>
+        <p:nvPicPr>
+          <p:cNvPr id="7" name="Picture 6" descr="flourish2.png"/>
+          <p:cNvPicPr>
+            <a:picLocks noChangeAspect="1"/>
+          </p:cNvPicPr>
+          <p:nvPr/>
+        </p:nvPicPr>
+        <p:blipFill>
+          <a:blip r:embed="rId2">
+            <a:duotone>
+              <a:prstClr val="black"/>
+              <a:schemeClr val="tx2">
+                <a:tint val="45000"/>
+                <a:satMod val="400000"/>
+              </a:schemeClr>
+            </a:duotone>
+            <a:lum bright="-14000"/>
+          </a:blip>
+          <a:stretch>
+            <a:fillRect/>
+          </a:stretch>
+        </p:blipFill>
         <p:spPr>
           <a:xfrm>
-            <a:off x="722313" y="4406900"/>
-            <a:ext cx="7772400" cy="1362075"/>
+            <a:off x="0" y="2684462"/>
+            <a:ext cx="12192000" cy="932688"/>
+          </a:xfrm>
+          <a:prstGeom prst="rect">
+            <a:avLst/>
+          </a:prstGeom>
+        </p:spPr>
+      </p:pic>
+      <p:sp>
+        <p:nvSpPr>
+          <p:cNvPr id="2" name="Title 1"/>
+          <p:cNvSpPr>
+            <a:spLocks noGrp="1"/>
+          </p:cNvSpPr>
+          <p:nvPr>
+            <p:ph type="title"/>
+          </p:nvPr>
+        </p:nvSpPr>
+        <p:spPr>
+          <a:xfrm>
+            <a:off x="1930400" y="3410268"/>
+            <a:ext cx="8331200" cy="1456373"/>
           </a:xfrm>
         </p:spPr>
         <p:txBody>
-          <a:bodyPr anchor="t"/>
+          <a:bodyPr anchor="t">
+            <a:normAutofit/>
+          </a:bodyPr>
           <a:lstStyle>
-            <a:lvl1pPr algn="l">
-              <a:defRPr sz="4000" b="1" cap="all"/>
+            <a:lvl1pPr algn="ctr">
+              <a:defRPr sz="3600" b="0" i="0" cap="all" baseline="0"/>
             </a:lvl1pPr>
           </a:lstStyle>
           <a:p>
@@ -923,7 +1077,7 @@
               <a:rPr lang="en-US" smtClean="0"/>
               <a:t>Click to edit Master title style</a:t>
             </a:r>
-            <a:endParaRPr lang="en-US"/>
+            <a:endParaRPr lang="en-US" dirty="0"/>
           </a:p>
         </p:txBody>
       </p:sp>
@@ -939,44 +1093,55 @@
         </p:nvSpPr>
         <p:spPr>
           <a:xfrm>
-            <a:off x="722313" y="2906713"/>
-            <a:ext cx="7772400" cy="1500187"/>
+            <a:off x="1930400" y="1503680"/>
+            <a:ext cx="8331200" cy="1566862"/>
           </a:xfrm>
         </p:spPr>
         <p:txBody>
           <a:bodyPr anchor="b"/>
           <a:lstStyle>
-            <a:lvl1pPr marL="0" indent="0">
-              <a:buNone/>
-              <a:defRPr sz="2000">
+            <a:lvl1pPr marL="0" indent="0" algn="ctr">
+              <a:buNone/>
+              <a:defRPr sz="2000" b="0" i="1" baseline="0">
+                <a:solidFill>
+                  <a:schemeClr val="tx1">
+                    <a:lumMod val="65000"/>
+                    <a:lumOff val="35000"/>
+                  </a:schemeClr>
+                </a:solidFill>
+              </a:defRPr>
+            </a:lvl1pPr>
+            <a:lvl2pPr marL="457200" indent="0">
+              <a:buNone/>
+              <a:defRPr sz="1800">
                 <a:solidFill>
                   <a:schemeClr val="tx1">
                     <a:tint val="75000"/>
                   </a:schemeClr>
                 </a:solidFill>
               </a:defRPr>
-            </a:lvl1pPr>
-            <a:lvl2pPr marL="457200" indent="0">
-              <a:buNone/>
-              <a:defRPr sz="1800">
+            </a:lvl2pPr>
+            <a:lvl3pPr marL="914400" indent="0">
+              <a:buNone/>
+              <a:defRPr sz="1600">
                 <a:solidFill>
                   <a:schemeClr val="tx1">
                     <a:tint val="75000"/>
                   </a:schemeClr>
                 </a:solidFill>
               </a:defRPr>
-            </a:lvl2pPr>
-            <a:lvl3pPr marL="914400" indent="0">
-              <a:buNone/>
-              <a:defRPr sz="1600">
+            </a:lvl3pPr>
+            <a:lvl4pPr marL="1371600" indent="0">
+              <a:buNone/>
+              <a:defRPr sz="1400">
                 <a:solidFill>
                   <a:schemeClr val="tx1">
                     <a:tint val="75000"/>
                   </a:schemeClr>
                 </a:solidFill>
               </a:defRPr>
-            </a:lvl3pPr>
-            <a:lvl4pPr marL="1371600" indent="0">
+            </a:lvl4pPr>
+            <a:lvl5pPr marL="1828800" indent="0">
               <a:buNone/>
               <a:defRPr sz="1400">
                 <a:solidFill>
@@ -985,8 +1150,8 @@
                   </a:schemeClr>
                 </a:solidFill>
               </a:defRPr>
-            </a:lvl4pPr>
-            <a:lvl5pPr marL="1828800" indent="0">
+            </a:lvl5pPr>
+            <a:lvl6pPr marL="2286000" indent="0">
               <a:buNone/>
               <a:defRPr sz="1400">
                 <a:solidFill>
@@ -995,8 +1160,8 @@
                   </a:schemeClr>
                 </a:solidFill>
               </a:defRPr>
-            </a:lvl5pPr>
-            <a:lvl6pPr marL="2286000" indent="0">
+            </a:lvl6pPr>
+            <a:lvl7pPr marL="2743200" indent="0">
               <a:buNone/>
               <a:defRPr sz="1400">
                 <a:solidFill>
@@ -1005,8 +1170,8 @@
                   </a:schemeClr>
                 </a:solidFill>
               </a:defRPr>
-            </a:lvl6pPr>
-            <a:lvl7pPr marL="2743200" indent="0">
+            </a:lvl7pPr>
+            <a:lvl8pPr marL="3200400" indent="0">
               <a:buNone/>
               <a:defRPr sz="1400">
                 <a:solidFill>
@@ -1015,8 +1180,8 @@
                   </a:schemeClr>
                 </a:solidFill>
               </a:defRPr>
-            </a:lvl7pPr>
-            <a:lvl8pPr marL="3200400" indent="0">
+            </a:lvl8pPr>
+            <a:lvl9pPr marL="3657600" indent="0">
               <a:buNone/>
               <a:defRPr sz="1400">
                 <a:solidFill>
@@ -1025,16 +1190,6 @@
                   </a:schemeClr>
                 </a:solidFill>
               </a:defRPr>
-            </a:lvl8pPr>
-            <a:lvl9pPr marL="3657600" indent="0">
-              <a:buNone/>
-              <a:defRPr sz="1400">
-                <a:solidFill>
-                  <a:schemeClr val="tx1">
-                    <a:tint val="75000"/>
-                  </a:schemeClr>
-                </a:solidFill>
-              </a:defRPr>
             </a:lvl9pPr>
           </a:lstStyle>
           <a:p>
@@ -1046,77 +1201,40 @@
           </a:p>
         </p:txBody>
       </p:sp>
-      <p:sp>
-        <p:nvSpPr>
-          <p:cNvPr id="4" name="Date Placeholder 3"/>
-          <p:cNvSpPr>
-            <a:spLocks noGrp="1"/>
-          </p:cNvSpPr>
-          <p:nvPr>
-            <p:ph type="dt" sz="half" idx="10"/>
-          </p:nvPr>
-        </p:nvSpPr>
-        <p:spPr/>
-        <p:txBody>
-          <a:bodyPr/>
-          <a:lstStyle/>
-          <a:p>
-            <a:fld id="{5BCAD085-E8A6-8845-BD4E-CB4CCA059FC4}" type="datetimeFigureOut">
-              <a:rPr lang="en-US" smtClean="0"/>
-              <a:t>1/27/13</a:t>
-            </a:fld>
-            <a:endParaRPr lang="en-US"/>
-          </a:p>
-        </p:txBody>
-      </p:sp>
-      <p:sp>
-        <p:nvSpPr>
-          <p:cNvPr id="5" name="Footer Placeholder 4"/>
-          <p:cNvSpPr>
-            <a:spLocks noGrp="1"/>
-          </p:cNvSpPr>
-          <p:nvPr>
-            <p:ph type="ftr" sz="quarter" idx="11"/>
-          </p:nvPr>
-        </p:nvSpPr>
-        <p:spPr/>
-        <p:txBody>
-          <a:bodyPr/>
-          <a:lstStyle/>
-          <a:p>
-            <a:endParaRPr lang="en-US"/>
-          </a:p>
-        </p:txBody>
-      </p:sp>
-      <p:sp>
-        <p:nvSpPr>
-          <p:cNvPr id="6" name="Slide Number Placeholder 5"/>
-          <p:cNvSpPr>
-            <a:spLocks noGrp="1"/>
-          </p:cNvSpPr>
-          <p:nvPr>
-            <p:ph type="sldNum" sz="quarter" idx="12"/>
-          </p:nvPr>
-        </p:nvSpPr>
-        <p:spPr/>
-        <p:txBody>
-          <a:bodyPr/>
-          <a:lstStyle/>
-          <a:p>
-            <a:fld id="{C1FF6DA9-008F-8B48-92A6-B652298478BF}" type="slidenum">
-              <a:rPr lang="en-US" smtClean="0"/>
-              <a:t>‹#›</a:t>
-            </a:fld>
-            <a:endParaRPr lang="en-US"/>
-          </a:p>
-        </p:txBody>
-      </p:sp>
+      <p:pic>
+        <p:nvPicPr>
+          <p:cNvPr id="8" name="Picture 7" descr="flourish2.png"/>
+          <p:cNvPicPr>
+            <a:picLocks noChangeAspect="1"/>
+          </p:cNvPicPr>
+          <p:nvPr/>
+        </p:nvPicPr>
+        <p:blipFill>
+          <a:blip r:embed="rId2">
+            <a:duotone>
+              <a:prstClr val="black"/>
+              <a:schemeClr val="tx2">
+                <a:tint val="45000"/>
+                <a:satMod val="400000"/>
+              </a:schemeClr>
+            </a:duotone>
+            <a:lum bright="-14000"/>
+          </a:blip>
+          <a:stretch>
+            <a:fillRect/>
+          </a:stretch>
+        </p:blipFill>
+        <p:spPr>
+          <a:xfrm>
+            <a:off x="0" y="2684462"/>
+            <a:ext cx="12192000" cy="932688"/>
+          </a:xfrm>
+          <a:prstGeom prst="rect">
+            <a:avLst/>
+          </a:prstGeom>
+        </p:spPr>
+      </p:pic>
     </p:spTree>
-    <p:extLst>
-      <p:ext uri="{BB962C8B-B14F-4D97-AF65-F5344CB8AC3E}">
-        <p14:creationId xmlns:p14="http://schemas.microsoft.com/office/powerpoint/2010/main" val="960648375"/>
-      </p:ext>
-    </p:extLst>
   </p:cSld>
   <p:clrMapOvr>
     <a:masterClrMapping/>
@@ -1143,74 +1261,23 @@
       </p:grpSpPr>
       <p:sp>
         <p:nvSpPr>
-          <p:cNvPr id="2" name="Title 1"/>
-          <p:cNvSpPr>
-            <a:spLocks noGrp="1"/>
-          </p:cNvSpPr>
-          <p:nvPr>
-            <p:ph type="title"/>
-          </p:nvPr>
-        </p:nvSpPr>
-        <p:spPr/>
-        <p:txBody>
-          <a:bodyPr/>
-          <a:lstStyle/>
-          <a:p>
-            <a:r>
-              <a:rPr lang="en-US" smtClean="0"/>
-              <a:t>Click to edit Master title style</a:t>
-            </a:r>
-            <a:endParaRPr lang="en-US"/>
-          </a:p>
-        </p:txBody>
-      </p:sp>
-      <p:sp>
-        <p:nvSpPr>
-          <p:cNvPr id="3" name="Content Placeholder 2"/>
-          <p:cNvSpPr>
-            <a:spLocks noGrp="1"/>
-          </p:cNvSpPr>
-          <p:nvPr>
-            <p:ph sz="half" idx="1"/>
+          <p:cNvPr id="10" name="Content Placeholder 9"/>
+          <p:cNvSpPr>
+            <a:spLocks noGrp="1"/>
+          </p:cNvSpPr>
+          <p:nvPr>
+            <p:ph sz="quarter" idx="13"/>
           </p:nvPr>
         </p:nvSpPr>
         <p:spPr>
           <a:xfrm>
-            <a:off x="457200" y="1600200"/>
-            <a:ext cx="4038600" cy="4525963"/>
+            <a:off x="1828800" y="2438400"/>
+            <a:ext cx="4165600" cy="3124200"/>
           </a:xfrm>
         </p:spPr>
         <p:txBody>
           <a:bodyPr/>
-          <a:lstStyle>
-            <a:lvl1pPr>
-              <a:defRPr sz="2800"/>
-            </a:lvl1pPr>
-            <a:lvl2pPr>
-              <a:defRPr sz="2400"/>
-            </a:lvl2pPr>
-            <a:lvl3pPr>
-              <a:defRPr sz="2000"/>
-            </a:lvl3pPr>
-            <a:lvl4pPr>
-              <a:defRPr sz="1800"/>
-            </a:lvl4pPr>
-            <a:lvl5pPr>
-              <a:defRPr sz="1800"/>
-            </a:lvl5pPr>
-            <a:lvl6pPr>
-              <a:defRPr sz="1800"/>
-            </a:lvl6pPr>
-            <a:lvl7pPr>
-              <a:defRPr sz="1800"/>
-            </a:lvl7pPr>
-            <a:lvl8pPr>
-              <a:defRPr sz="1800"/>
-            </a:lvl8pPr>
-            <a:lvl9pPr>
-              <a:defRPr sz="1800"/>
-            </a:lvl9pPr>
-          </a:lstStyle>
+          <a:lstStyle/>
           <a:p>
             <a:pPr lvl="0"/>
             <a:r>
@@ -1245,113 +1312,51 @@
               <a:rPr lang="en-US" smtClean="0"/>
               <a:t>Fifth level</a:t>
             </a:r>
+            <a:endParaRPr lang="en-US" dirty="0"/>
+          </a:p>
+        </p:txBody>
+      </p:sp>
+      <p:sp>
+        <p:nvSpPr>
+          <p:cNvPr id="2" name="Title 1"/>
+          <p:cNvSpPr>
+            <a:spLocks noGrp="1"/>
+          </p:cNvSpPr>
+          <p:nvPr>
+            <p:ph type="title"/>
+          </p:nvPr>
+        </p:nvSpPr>
+        <p:spPr/>
+        <p:txBody>
+          <a:bodyPr/>
+          <a:lstStyle/>
+          <a:p>
+            <a:r>
+              <a:rPr lang="en-US" smtClean="0"/>
+              <a:t>Click to edit Master title style</a:t>
+            </a:r>
             <a:endParaRPr lang="en-US"/>
           </a:p>
         </p:txBody>
       </p:sp>
       <p:sp>
         <p:nvSpPr>
-          <p:cNvPr id="4" name="Content Placeholder 3"/>
-          <p:cNvSpPr>
-            <a:spLocks noGrp="1"/>
-          </p:cNvSpPr>
-          <p:nvPr>
-            <p:ph sz="half" idx="2"/>
-          </p:nvPr>
-        </p:nvSpPr>
-        <p:spPr>
-          <a:xfrm>
-            <a:off x="4648200" y="1600200"/>
-            <a:ext cx="4038600" cy="4525963"/>
-          </a:xfrm>
-        </p:spPr>
+          <p:cNvPr id="5" name="Date Placeholder 4"/>
+          <p:cNvSpPr>
+            <a:spLocks noGrp="1"/>
+          </p:cNvSpPr>
+          <p:nvPr>
+            <p:ph type="dt" sz="half" idx="10"/>
+          </p:nvPr>
+        </p:nvSpPr>
+        <p:spPr/>
         <p:txBody>
           <a:bodyPr/>
-          <a:lstStyle>
-            <a:lvl1pPr>
-              <a:defRPr sz="2800"/>
-            </a:lvl1pPr>
-            <a:lvl2pPr>
-              <a:defRPr sz="2400"/>
-            </a:lvl2pPr>
-            <a:lvl3pPr>
-              <a:defRPr sz="2000"/>
-            </a:lvl3pPr>
-            <a:lvl4pPr>
-              <a:defRPr sz="1800"/>
-            </a:lvl4pPr>
-            <a:lvl5pPr>
-              <a:defRPr sz="1800"/>
-            </a:lvl5pPr>
-            <a:lvl6pPr>
-              <a:defRPr sz="1800"/>
-            </a:lvl6pPr>
-            <a:lvl7pPr>
-              <a:defRPr sz="1800"/>
-            </a:lvl7pPr>
-            <a:lvl8pPr>
-              <a:defRPr sz="1800"/>
-            </a:lvl8pPr>
-            <a:lvl9pPr>
-              <a:defRPr sz="1800"/>
-            </a:lvl9pPr>
-          </a:lstStyle>
-          <a:p>
-            <a:pPr lvl="0"/>
-            <a:r>
-              <a:rPr lang="en-US" smtClean="0"/>
-              <a:t>Click to edit Master text styles</a:t>
-            </a:r>
-          </a:p>
-          <a:p>
-            <a:pPr lvl="1"/>
-            <a:r>
-              <a:rPr lang="en-US" smtClean="0"/>
-              <a:t>Second level</a:t>
-            </a:r>
-          </a:p>
-          <a:p>
-            <a:pPr lvl="2"/>
-            <a:r>
-              <a:rPr lang="en-US" smtClean="0"/>
-              <a:t>Third level</a:t>
-            </a:r>
-          </a:p>
-          <a:p>
-            <a:pPr lvl="3"/>
-            <a:r>
-              <a:rPr lang="en-US" smtClean="0"/>
-              <a:t>Fourth level</a:t>
-            </a:r>
-          </a:p>
-          <a:p>
-            <a:pPr lvl="4"/>
-            <a:r>
-              <a:rPr lang="en-US" smtClean="0"/>
-              <a:t>Fifth level</a:t>
-            </a:r>
-            <a:endParaRPr lang="en-US"/>
-          </a:p>
-        </p:txBody>
-      </p:sp>
-      <p:sp>
-        <p:nvSpPr>
-          <p:cNvPr id="5" name="Date Placeholder 4"/>
-          <p:cNvSpPr>
-            <a:spLocks noGrp="1"/>
-          </p:cNvSpPr>
-          <p:nvPr>
-            <p:ph type="dt" sz="half" idx="10"/>
-          </p:nvPr>
-        </p:nvSpPr>
-        <p:spPr/>
-        <p:txBody>
-          <a:bodyPr/>
           <a:lstStyle/>
           <a:p>
             <a:fld id="{5BCAD085-E8A6-8845-BD4E-CB4CCA059FC4}" type="datetimeFigureOut">
               <a:rPr lang="en-US" smtClean="0"/>
-              <a:t>1/27/13</a:t>
+              <a:t>9/18/2026</a:t>
             </a:fld>
             <a:endParaRPr lang="en-US"/>
           </a:p>
@@ -1399,12 +1404,97 @@
           </a:p>
         </p:txBody>
       </p:sp>
+      <p:sp>
+        <p:nvSpPr>
+          <p:cNvPr id="12" name="Content Placeholder 11"/>
+          <p:cNvSpPr>
+            <a:spLocks noGrp="1"/>
+          </p:cNvSpPr>
+          <p:nvPr>
+            <p:ph sz="quarter" idx="14"/>
+          </p:nvPr>
+        </p:nvSpPr>
+        <p:spPr>
+          <a:xfrm>
+            <a:off x="6197600" y="2438400"/>
+            <a:ext cx="4165600" cy="3124200"/>
+          </a:xfrm>
+        </p:spPr>
+        <p:txBody>
+          <a:bodyPr/>
+          <a:lstStyle/>
+          <a:p>
+            <a:pPr lvl="0"/>
+            <a:r>
+              <a:rPr lang="en-US" smtClean="0"/>
+              <a:t>Click to edit Master text styles</a:t>
+            </a:r>
+          </a:p>
+          <a:p>
+            <a:pPr lvl="1"/>
+            <a:r>
+              <a:rPr lang="en-US" smtClean="0"/>
+              <a:t>Second level</a:t>
+            </a:r>
+          </a:p>
+          <a:p>
+            <a:pPr lvl="2"/>
+            <a:r>
+              <a:rPr lang="en-US" smtClean="0"/>
+              <a:t>Third level</a:t>
+            </a:r>
+          </a:p>
+          <a:p>
+            <a:pPr lvl="3"/>
+            <a:r>
+              <a:rPr lang="en-US" smtClean="0"/>
+              <a:t>Fourth level</a:t>
+            </a:r>
+          </a:p>
+          <a:p>
+            <a:pPr lvl="4"/>
+            <a:r>
+              <a:rPr lang="en-US" smtClean="0"/>
+              <a:t>Fifth level</a:t>
+            </a:r>
+            <a:endParaRPr lang="en-US" dirty="0"/>
+          </a:p>
+        </p:txBody>
+      </p:sp>
+      <p:pic>
+        <p:nvPicPr>
+          <p:cNvPr id="9" name="Picture 8" descr="flourish2.png"/>
+          <p:cNvPicPr>
+            <a:picLocks noChangeAspect="1"/>
+          </p:cNvPicPr>
+          <p:nvPr/>
+        </p:nvPicPr>
+        <p:blipFill>
+          <a:blip r:embed="rId2">
+            <a:duotone>
+              <a:prstClr val="black"/>
+              <a:schemeClr val="tx2">
+                <a:tint val="45000"/>
+                <a:satMod val="400000"/>
+              </a:schemeClr>
+            </a:duotone>
+            <a:lum bright="-14000"/>
+          </a:blip>
+          <a:stretch>
+            <a:fillRect/>
+          </a:stretch>
+        </p:blipFill>
+        <p:spPr>
+          <a:xfrm>
+            <a:off x="0" y="1618488"/>
+            <a:ext cx="12192000" cy="932688"/>
+          </a:xfrm>
+          <a:prstGeom prst="rect">
+            <a:avLst/>
+          </a:prstGeom>
+        </p:spPr>
+      </p:pic>
     </p:spTree>
-    <p:extLst>
-      <p:ext uri="{BB962C8B-B14F-4D97-AF65-F5344CB8AC3E}">
-        <p14:creationId xmlns:p14="http://schemas.microsoft.com/office/powerpoint/2010/main" val="2782244947"/>
-      </p:ext>
-    </p:extLst>
   </p:cSld>
   <p:clrMapOvr>
     <a:masterClrMapping/>
@@ -1429,6 +1519,158 @@
           <a:chExt cx="0" cy="0"/>
         </a:xfrm>
       </p:grpSpPr>
+      <p:pic>
+        <p:nvPicPr>
+          <p:cNvPr id="12" name="Picture 11" descr="flourish2.png"/>
+          <p:cNvPicPr>
+            <a:picLocks noChangeAspect="1"/>
+          </p:cNvPicPr>
+          <p:nvPr/>
+        </p:nvPicPr>
+        <p:blipFill>
+          <a:blip r:embed="rId2">
+            <a:clrChange>
+              <a:clrFrom>
+                <a:srgbClr val="000000">
+                  <a:alpha val="0"/>
+                </a:srgbClr>
+              </a:clrFrom>
+              <a:clrTo>
+                <a:srgbClr val="000000">
+                  <a:alpha val="0"/>
+                </a:srgbClr>
+              </a:clrTo>
+            </a:clrChange>
+            <a:lum bright="-14000"/>
+          </a:blip>
+          <a:stretch>
+            <a:fillRect/>
+          </a:stretch>
+        </p:blipFill>
+        <p:spPr>
+          <a:xfrm>
+            <a:off x="0" y="1618488"/>
+            <a:ext cx="12192000" cy="932688"/>
+          </a:xfrm>
+          <a:prstGeom prst="rect">
+            <a:avLst/>
+          </a:prstGeom>
+        </p:spPr>
+      </p:pic>
+      <p:sp>
+        <p:nvSpPr>
+          <p:cNvPr id="11" name="Content Placeholder 10"/>
+          <p:cNvSpPr>
+            <a:spLocks noGrp="1"/>
+          </p:cNvSpPr>
+          <p:nvPr>
+            <p:ph sz="quarter" idx="13"/>
+          </p:nvPr>
+        </p:nvSpPr>
+        <p:spPr>
+          <a:xfrm>
+            <a:off x="1828800" y="2819400"/>
+            <a:ext cx="4165600" cy="2743200"/>
+          </a:xfrm>
+        </p:spPr>
+        <p:txBody>
+          <a:bodyPr/>
+          <a:lstStyle/>
+          <a:p>
+            <a:pPr lvl="0"/>
+            <a:r>
+              <a:rPr lang="en-US" smtClean="0"/>
+              <a:t>Click to edit Master text styles</a:t>
+            </a:r>
+          </a:p>
+          <a:p>
+            <a:pPr lvl="1"/>
+            <a:r>
+              <a:rPr lang="en-US" smtClean="0"/>
+              <a:t>Second level</a:t>
+            </a:r>
+          </a:p>
+          <a:p>
+            <a:pPr lvl="2"/>
+            <a:r>
+              <a:rPr lang="en-US" smtClean="0"/>
+              <a:t>Third level</a:t>
+            </a:r>
+          </a:p>
+          <a:p>
+            <a:pPr lvl="3"/>
+            <a:r>
+              <a:rPr lang="en-US" smtClean="0"/>
+              <a:t>Fourth level</a:t>
+            </a:r>
+          </a:p>
+          <a:p>
+            <a:pPr lvl="4"/>
+            <a:r>
+              <a:rPr lang="en-US" smtClean="0"/>
+              <a:t>Fifth level</a:t>
+            </a:r>
+            <a:endParaRPr lang="en-US" dirty="0"/>
+          </a:p>
+        </p:txBody>
+      </p:sp>
+      <p:sp>
+        <p:nvSpPr>
+          <p:cNvPr id="13" name="Content Placeholder 12"/>
+          <p:cNvSpPr>
+            <a:spLocks noGrp="1"/>
+          </p:cNvSpPr>
+          <p:nvPr>
+            <p:ph sz="quarter" idx="14"/>
+          </p:nvPr>
+        </p:nvSpPr>
+        <p:spPr>
+          <a:xfrm>
+            <a:off x="6197600" y="2819400"/>
+            <a:ext cx="4165600" cy="2743200"/>
+          </a:xfrm>
+        </p:spPr>
+        <p:txBody>
+          <a:bodyPr/>
+          <a:lstStyle/>
+          <a:p>
+            <a:pPr lvl="0"/>
+            <a:r>
+              <a:rPr lang="en-US" smtClean="0"/>
+              <a:t>Click to edit Master text styles</a:t>
+            </a:r>
+          </a:p>
+          <a:p>
+            <a:pPr lvl="1"/>
+            <a:r>
+              <a:rPr lang="en-US" smtClean="0"/>
+              <a:t>Second level</a:t>
+            </a:r>
+          </a:p>
+          <a:p>
+            <a:pPr lvl="2"/>
+            <a:r>
+              <a:rPr lang="en-US" smtClean="0"/>
+              <a:t>Third level</a:t>
+            </a:r>
+          </a:p>
+          <a:p>
+            <a:pPr lvl="3"/>
+            <a:r>
+              <a:rPr lang="en-US" smtClean="0"/>
+              <a:t>Fourth level</a:t>
+            </a:r>
+          </a:p>
+          <a:p>
+            <a:pPr lvl="4"/>
+            <a:r>
+              <a:rPr lang="en-US" smtClean="0"/>
+              <a:t>Fifth level</a:t>
+            </a:r>
+            <a:endParaRPr lang="en-US" dirty="0"/>
+          </a:p>
+        </p:txBody>
+      </p:sp>
       <p:sp>
         <p:nvSpPr>
           <p:cNvPr id="2" name="Title 1"/>
@@ -1468,16 +1710,16 @@
         </p:nvSpPr>
         <p:spPr>
           <a:xfrm>
-            <a:off x="457200" y="1535113"/>
-            <a:ext cx="4040188" cy="639762"/>
+            <a:off x="1828800" y="2362201"/>
+            <a:ext cx="4167717" cy="451338"/>
           </a:xfrm>
         </p:spPr>
         <p:txBody>
           <a:bodyPr anchor="b"/>
           <a:lstStyle>
-            <a:lvl1pPr marL="0" indent="0">
-              <a:buNone/>
-              <a:defRPr sz="2400" b="1"/>
+            <a:lvl1pPr marL="0" indent="0" algn="ctr">
+              <a:buNone/>
+              <a:defRPr sz="1800" b="1" baseline="0"/>
             </a:lvl1pPr>
             <a:lvl2pPr marL="457200" indent="0">
               <a:buNone/>
@@ -1523,111 +1765,26 @@
       </p:sp>
       <p:sp>
         <p:nvSpPr>
-          <p:cNvPr id="4" name="Content Placeholder 3"/>
-          <p:cNvSpPr>
-            <a:spLocks noGrp="1"/>
-          </p:cNvSpPr>
-          <p:nvPr>
-            <p:ph sz="half" idx="2"/>
+          <p:cNvPr id="5" name="Text Placeholder 4"/>
+          <p:cNvSpPr>
+            <a:spLocks noGrp="1"/>
+          </p:cNvSpPr>
+          <p:nvPr>
+            <p:ph type="body" sz="quarter" idx="3"/>
           </p:nvPr>
         </p:nvSpPr>
         <p:spPr>
           <a:xfrm>
-            <a:off x="457200" y="2174875"/>
-            <a:ext cx="4040188" cy="3951288"/>
+            <a:off x="6193368" y="2359152"/>
+            <a:ext cx="4169833" cy="448056"/>
           </a:xfrm>
         </p:spPr>
         <p:txBody>
-          <a:bodyPr/>
-          <a:lstStyle>
-            <a:lvl1pPr>
-              <a:defRPr sz="2400"/>
-            </a:lvl1pPr>
-            <a:lvl2pPr>
-              <a:defRPr sz="2000"/>
-            </a:lvl2pPr>
-            <a:lvl3pPr>
-              <a:defRPr sz="1800"/>
-            </a:lvl3pPr>
-            <a:lvl4pPr>
-              <a:defRPr sz="1600"/>
-            </a:lvl4pPr>
-            <a:lvl5pPr>
-              <a:defRPr sz="1600"/>
-            </a:lvl5pPr>
-            <a:lvl6pPr>
-              <a:defRPr sz="1600"/>
-            </a:lvl6pPr>
-            <a:lvl7pPr>
-              <a:defRPr sz="1600"/>
-            </a:lvl7pPr>
-            <a:lvl8pPr>
-              <a:defRPr sz="1600"/>
-            </a:lvl8pPr>
-            <a:lvl9pPr>
-              <a:defRPr sz="1600"/>
-            </a:lvl9pPr>
-          </a:lstStyle>
-          <a:p>
-            <a:pPr lvl="0"/>
-            <a:r>
-              <a:rPr lang="en-US" smtClean="0"/>
-              <a:t>Click to edit Master text styles</a:t>
-            </a:r>
-          </a:p>
-          <a:p>
-            <a:pPr lvl="1"/>
-            <a:r>
-              <a:rPr lang="en-US" smtClean="0"/>
-              <a:t>Second level</a:t>
-            </a:r>
-          </a:p>
-          <a:p>
-            <a:pPr lvl="2"/>
-            <a:r>
-              <a:rPr lang="en-US" smtClean="0"/>
-              <a:t>Third level</a:t>
-            </a:r>
-          </a:p>
-          <a:p>
-            <a:pPr lvl="3"/>
-            <a:r>
-              <a:rPr lang="en-US" smtClean="0"/>
-              <a:t>Fourth level</a:t>
-            </a:r>
-          </a:p>
-          <a:p>
-            <a:pPr lvl="4"/>
-            <a:r>
-              <a:rPr lang="en-US" smtClean="0"/>
-              <a:t>Fifth level</a:t>
-            </a:r>
-            <a:endParaRPr lang="en-US"/>
-          </a:p>
-        </p:txBody>
-      </p:sp>
-      <p:sp>
-        <p:nvSpPr>
-          <p:cNvPr id="5" name="Text Placeholder 4"/>
-          <p:cNvSpPr>
-            <a:spLocks noGrp="1"/>
-          </p:cNvSpPr>
-          <p:nvPr>
-            <p:ph type="body" sz="quarter" idx="3"/>
-          </p:nvPr>
-        </p:nvSpPr>
-        <p:spPr>
-          <a:xfrm>
-            <a:off x="4645025" y="1535113"/>
-            <a:ext cx="4041775" cy="639762"/>
-          </a:xfrm>
-        </p:spPr>
-        <p:txBody>
           <a:bodyPr anchor="b"/>
           <a:lstStyle>
-            <a:lvl1pPr marL="0" indent="0">
-              <a:buNone/>
-              <a:defRPr sz="2400" b="1"/>
+            <a:lvl1pPr marL="0" indent="0" algn="ctr">
+              <a:buNone/>
+              <a:defRPr sz="1800" b="1" baseline="0"/>
             </a:lvl1pPr>
             <a:lvl2pPr marL="457200" indent="0">
               <a:buNone/>
@@ -1673,107 +1830,22 @@
       </p:sp>
       <p:sp>
         <p:nvSpPr>
-          <p:cNvPr id="6" name="Content Placeholder 5"/>
-          <p:cNvSpPr>
-            <a:spLocks noGrp="1"/>
-          </p:cNvSpPr>
-          <p:nvPr>
-            <p:ph sz="quarter" idx="4"/>
-          </p:nvPr>
-        </p:nvSpPr>
-        <p:spPr>
-          <a:xfrm>
-            <a:off x="4645025" y="2174875"/>
-            <a:ext cx="4041775" cy="3951288"/>
-          </a:xfrm>
-        </p:spPr>
+          <p:cNvPr id="7" name="Date Placeholder 6"/>
+          <p:cNvSpPr>
+            <a:spLocks noGrp="1"/>
+          </p:cNvSpPr>
+          <p:nvPr>
+            <p:ph type="dt" sz="half" idx="10"/>
+          </p:nvPr>
+        </p:nvSpPr>
+        <p:spPr/>
         <p:txBody>
           <a:bodyPr/>
-          <a:lstStyle>
-            <a:lvl1pPr>
-              <a:defRPr sz="2400"/>
-            </a:lvl1pPr>
-            <a:lvl2pPr>
-              <a:defRPr sz="2000"/>
-            </a:lvl2pPr>
-            <a:lvl3pPr>
-              <a:defRPr sz="1800"/>
-            </a:lvl3pPr>
-            <a:lvl4pPr>
-              <a:defRPr sz="1600"/>
-            </a:lvl4pPr>
-            <a:lvl5pPr>
-              <a:defRPr sz="1600"/>
-            </a:lvl5pPr>
-            <a:lvl6pPr>
-              <a:defRPr sz="1600"/>
-            </a:lvl6pPr>
-            <a:lvl7pPr>
-              <a:defRPr sz="1600"/>
-            </a:lvl7pPr>
-            <a:lvl8pPr>
-              <a:defRPr sz="1600"/>
-            </a:lvl8pPr>
-            <a:lvl9pPr>
-              <a:defRPr sz="1600"/>
-            </a:lvl9pPr>
-          </a:lstStyle>
-          <a:p>
-            <a:pPr lvl="0"/>
-            <a:r>
-              <a:rPr lang="en-US" smtClean="0"/>
-              <a:t>Click to edit Master text styles</a:t>
-            </a:r>
-          </a:p>
-          <a:p>
-            <a:pPr lvl="1"/>
-            <a:r>
-              <a:rPr lang="en-US" smtClean="0"/>
-              <a:t>Second level</a:t>
-            </a:r>
-          </a:p>
-          <a:p>
-            <a:pPr lvl="2"/>
-            <a:r>
-              <a:rPr lang="en-US" smtClean="0"/>
-              <a:t>Third level</a:t>
-            </a:r>
-          </a:p>
-          <a:p>
-            <a:pPr lvl="3"/>
-            <a:r>
-              <a:rPr lang="en-US" smtClean="0"/>
-              <a:t>Fourth level</a:t>
-            </a:r>
-          </a:p>
-          <a:p>
-            <a:pPr lvl="4"/>
-            <a:r>
-              <a:rPr lang="en-US" smtClean="0"/>
-              <a:t>Fifth level</a:t>
-            </a:r>
-            <a:endParaRPr lang="en-US"/>
-          </a:p>
-        </p:txBody>
-      </p:sp>
-      <p:sp>
-        <p:nvSpPr>
-          <p:cNvPr id="7" name="Date Placeholder 6"/>
-          <p:cNvSpPr>
-            <a:spLocks noGrp="1"/>
-          </p:cNvSpPr>
-          <p:nvPr>
-            <p:ph type="dt" sz="half" idx="10"/>
-          </p:nvPr>
-        </p:nvSpPr>
-        <p:spPr/>
-        <p:txBody>
-          <a:bodyPr/>
           <a:lstStyle/>
           <a:p>
             <a:fld id="{5BCAD085-E8A6-8845-BD4E-CB4CCA059FC4}" type="datetimeFigureOut">
               <a:rPr lang="en-US" smtClean="0"/>
-              <a:t>1/27/13</a:t>
+              <a:t>9/18/2026</a:t>
             </a:fld>
             <a:endParaRPr lang="en-US"/>
           </a:p>
@@ -1822,11 +1894,6 @@
         </p:txBody>
       </p:sp>
     </p:spTree>
-    <p:extLst>
-      <p:ext uri="{BB962C8B-B14F-4D97-AF65-F5344CB8AC3E}">
-        <p14:creationId xmlns:p14="http://schemas.microsoft.com/office/powerpoint/2010/main" val="990158736"/>
-      </p:ext>
-    </p:extLst>
   </p:cSld>
   <p:clrMapOvr>
     <a:masterClrMapping/>
@@ -1891,7 +1958,7 @@
           <a:p>
             <a:fld id="{5BCAD085-E8A6-8845-BD4E-CB4CCA059FC4}" type="datetimeFigureOut">
               <a:rPr lang="en-US" smtClean="0"/>
-              <a:t>1/27/13</a:t>
+              <a:t>9/18/2026</a:t>
             </a:fld>
             <a:endParaRPr lang="en-US"/>
           </a:p>
@@ -1939,12 +2006,40 @@
           </a:p>
         </p:txBody>
       </p:sp>
+      <p:pic>
+        <p:nvPicPr>
+          <p:cNvPr id="7" name="Picture 6" descr="flourish2.png"/>
+          <p:cNvPicPr>
+            <a:picLocks noChangeAspect="1"/>
+          </p:cNvPicPr>
+          <p:nvPr/>
+        </p:nvPicPr>
+        <p:blipFill>
+          <a:blip r:embed="rId2">
+            <a:duotone>
+              <a:prstClr val="black"/>
+              <a:schemeClr val="tx2">
+                <a:tint val="45000"/>
+                <a:satMod val="400000"/>
+              </a:schemeClr>
+            </a:duotone>
+            <a:lum bright="-14000"/>
+          </a:blip>
+          <a:stretch>
+            <a:fillRect/>
+          </a:stretch>
+        </p:blipFill>
+        <p:spPr>
+          <a:xfrm>
+            <a:off x="0" y="1618488"/>
+            <a:ext cx="12192000" cy="932688"/>
+          </a:xfrm>
+          <a:prstGeom prst="rect">
+            <a:avLst/>
+          </a:prstGeom>
+        </p:spPr>
+      </p:pic>
     </p:spTree>
-    <p:extLst>
-      <p:ext uri="{BB962C8B-B14F-4D97-AF65-F5344CB8AC3E}">
-        <p14:creationId xmlns:p14="http://schemas.microsoft.com/office/powerpoint/2010/main" val="727027711"/>
-      </p:ext>
-    </p:extLst>
   </p:cSld>
   <p:clrMapOvr>
     <a:masterClrMapping/>
@@ -1971,7 +2066,7 @@
       </p:grpSpPr>
       <p:sp>
         <p:nvSpPr>
-          <p:cNvPr id="2" name="Date Placeholder 1"/>
+          <p:cNvPr id="5" name="Date Placeholder 4"/>
           <p:cNvSpPr>
             <a:spLocks noGrp="1"/>
           </p:cNvSpPr>
@@ -1986,7 +2081,7 @@
           <a:p>
             <a:fld id="{5BCAD085-E8A6-8845-BD4E-CB4CCA059FC4}" type="datetimeFigureOut">
               <a:rPr lang="en-US" smtClean="0"/>
-              <a:t>1/27/13</a:t>
+              <a:t>9/18/2026</a:t>
             </a:fld>
             <a:endParaRPr lang="en-US"/>
           </a:p>
@@ -1994,7 +2089,7 @@
       </p:sp>
       <p:sp>
         <p:nvSpPr>
-          <p:cNvPr id="3" name="Footer Placeholder 2"/>
+          <p:cNvPr id="6" name="Footer Placeholder 5"/>
           <p:cNvSpPr>
             <a:spLocks noGrp="1"/>
           </p:cNvSpPr>
@@ -2013,7 +2108,7 @@
       </p:sp>
       <p:sp>
         <p:nvSpPr>
-          <p:cNvPr id="4" name="Slide Number Placeholder 3"/>
+          <p:cNvPr id="7" name="Slide Number Placeholder 6"/>
           <p:cNvSpPr>
             <a:spLocks noGrp="1"/>
           </p:cNvSpPr>
@@ -2035,11 +2130,6 @@
         </p:txBody>
       </p:sp>
     </p:spTree>
-    <p:extLst>
-      <p:ext uri="{BB962C8B-B14F-4D97-AF65-F5344CB8AC3E}">
-        <p14:creationId xmlns:p14="http://schemas.microsoft.com/office/powerpoint/2010/main" val="1212999818"/>
-      </p:ext>
-    </p:extLst>
   </p:cSld>
   <p:clrMapOvr>
     <a:masterClrMapping/>
@@ -2076,15 +2166,17 @@
         </p:nvSpPr>
         <p:spPr>
           <a:xfrm>
-            <a:off x="457200" y="273050"/>
-            <a:ext cx="3008313" cy="1162050"/>
+            <a:off x="6604002" y="1676400"/>
+            <a:ext cx="3759199" cy="599440"/>
           </a:xfrm>
         </p:spPr>
         <p:txBody>
-          <a:bodyPr anchor="b"/>
+          <a:bodyPr anchor="b">
+            <a:noAutofit/>
+          </a:bodyPr>
           <a:lstStyle>
-            <a:lvl1pPr algn="l">
-              <a:defRPr sz="2000" b="1"/>
+            <a:lvl1pPr algn="ctr">
+              <a:defRPr sz="1700" b="1" cap="all" spc="0" baseline="0"/>
             </a:lvl1pPr>
           </a:lstStyle>
           <a:p>
@@ -2092,115 +2184,30 @@
               <a:rPr lang="en-US" smtClean="0"/>
               <a:t>Click to edit Master title style</a:t>
             </a:r>
-            <a:endParaRPr lang="en-US"/>
-          </a:p>
-        </p:txBody>
-      </p:sp>
-      <p:sp>
-        <p:nvSpPr>
-          <p:cNvPr id="3" name="Content Placeholder 2"/>
-          <p:cNvSpPr>
-            <a:spLocks noGrp="1"/>
-          </p:cNvSpPr>
-          <p:nvPr>
-            <p:ph idx="1"/>
+            <a:endParaRPr lang="en-US" dirty="0"/>
+          </a:p>
+        </p:txBody>
+      </p:sp>
+      <p:sp>
+        <p:nvSpPr>
+          <p:cNvPr id="4" name="Text Placeholder 3"/>
+          <p:cNvSpPr>
+            <a:spLocks noGrp="1"/>
+          </p:cNvSpPr>
+          <p:nvPr>
+            <p:ph type="body" sz="half" idx="2"/>
           </p:nvPr>
         </p:nvSpPr>
         <p:spPr>
           <a:xfrm>
-            <a:off x="3575050" y="273050"/>
-            <a:ext cx="5111750" cy="5853113"/>
+            <a:off x="6604002" y="2275840"/>
+            <a:ext cx="3759199" cy="2905760"/>
           </a:xfrm>
         </p:spPr>
         <p:txBody>
           <a:bodyPr/>
           <a:lstStyle>
-            <a:lvl1pPr>
-              <a:defRPr sz="3200"/>
-            </a:lvl1pPr>
-            <a:lvl2pPr>
-              <a:defRPr sz="2800"/>
-            </a:lvl2pPr>
-            <a:lvl3pPr>
-              <a:defRPr sz="2400"/>
-            </a:lvl3pPr>
-            <a:lvl4pPr>
-              <a:defRPr sz="2000"/>
-            </a:lvl4pPr>
-            <a:lvl5pPr>
-              <a:defRPr sz="2000"/>
-            </a:lvl5pPr>
-            <a:lvl6pPr>
-              <a:defRPr sz="2000"/>
-            </a:lvl6pPr>
-            <a:lvl7pPr>
-              <a:defRPr sz="2000"/>
-            </a:lvl7pPr>
-            <a:lvl8pPr>
-              <a:defRPr sz="2000"/>
-            </a:lvl8pPr>
-            <a:lvl9pPr>
-              <a:defRPr sz="2000"/>
-            </a:lvl9pPr>
-          </a:lstStyle>
-          <a:p>
-            <a:pPr lvl="0"/>
-            <a:r>
-              <a:rPr lang="en-US" smtClean="0"/>
-              <a:t>Click to edit Master text styles</a:t>
-            </a:r>
-          </a:p>
-          <a:p>
-            <a:pPr lvl="1"/>
-            <a:r>
-              <a:rPr lang="en-US" smtClean="0"/>
-              <a:t>Second level</a:t>
-            </a:r>
-          </a:p>
-          <a:p>
-            <a:pPr lvl="2"/>
-            <a:r>
-              <a:rPr lang="en-US" smtClean="0"/>
-              <a:t>Third level</a:t>
-            </a:r>
-          </a:p>
-          <a:p>
-            <a:pPr lvl="3"/>
-            <a:r>
-              <a:rPr lang="en-US" smtClean="0"/>
-              <a:t>Fourth level</a:t>
-            </a:r>
-          </a:p>
-          <a:p>
-            <a:pPr lvl="4"/>
-            <a:r>
-              <a:rPr lang="en-US" smtClean="0"/>
-              <a:t>Fifth level</a:t>
-            </a:r>
-            <a:endParaRPr lang="en-US"/>
-          </a:p>
-        </p:txBody>
-      </p:sp>
-      <p:sp>
-        <p:nvSpPr>
-          <p:cNvPr id="4" name="Text Placeholder 3"/>
-          <p:cNvSpPr>
-            <a:spLocks noGrp="1"/>
-          </p:cNvSpPr>
-          <p:nvPr>
-            <p:ph type="body" sz="half" idx="2"/>
-          </p:nvPr>
-        </p:nvSpPr>
-        <p:spPr>
-          <a:xfrm>
-            <a:off x="457200" y="1435100"/>
-            <a:ext cx="3008313" cy="4691063"/>
-          </a:xfrm>
-        </p:spPr>
-        <p:txBody>
-          <a:bodyPr/>
-          <a:lstStyle>
-            <a:lvl1pPr marL="0" indent="0">
+            <a:lvl1pPr marL="0" indent="0" algn="ctr">
               <a:buNone/>
               <a:defRPr sz="1400"/>
             </a:lvl1pPr>
@@ -2263,7 +2270,7 @@
           <a:p>
             <a:fld id="{5BCAD085-E8A6-8845-BD4E-CB4CCA059FC4}" type="datetimeFigureOut">
               <a:rPr lang="en-US" smtClean="0"/>
-              <a:t>1/27/13</a:t>
+              <a:t>9/18/2026</a:t>
             </a:fld>
             <a:endParaRPr lang="en-US"/>
           </a:p>
@@ -2311,12 +2318,64 @@
           </a:p>
         </p:txBody>
       </p:sp>
+      <p:sp>
+        <p:nvSpPr>
+          <p:cNvPr id="9" name="Content Placeholder 8"/>
+          <p:cNvSpPr>
+            <a:spLocks noGrp="1"/>
+          </p:cNvSpPr>
+          <p:nvPr>
+            <p:ph sz="quarter" idx="13"/>
+          </p:nvPr>
+        </p:nvSpPr>
+        <p:spPr>
+          <a:xfrm>
+            <a:off x="1828800" y="1676400"/>
+            <a:ext cx="4368800" cy="3505200"/>
+          </a:xfrm>
+        </p:spPr>
+        <p:txBody>
+          <a:bodyPr/>
+          <a:lstStyle/>
+          <a:p>
+            <a:pPr lvl="0"/>
+            <a:r>
+              <a:rPr lang="en-US" smtClean="0"/>
+              <a:t>Click to edit Master text styles</a:t>
+            </a:r>
+          </a:p>
+          <a:p>
+            <a:pPr lvl="1"/>
+            <a:r>
+              <a:rPr lang="en-US" smtClean="0"/>
+              <a:t>Second level</a:t>
+            </a:r>
+          </a:p>
+          <a:p>
+            <a:pPr lvl="2"/>
+            <a:r>
+              <a:rPr lang="en-US" smtClean="0"/>
+              <a:t>Third level</a:t>
+            </a:r>
+          </a:p>
+          <a:p>
+            <a:pPr lvl="3"/>
+            <a:r>
+              <a:rPr lang="en-US" smtClean="0"/>
+              <a:t>Fourth level</a:t>
+            </a:r>
+          </a:p>
+          <a:p>
+            <a:pPr lvl="4"/>
+            <a:r>
+              <a:rPr lang="en-US" smtClean="0"/>
+              <a:t>Fifth level</a:t>
+            </a:r>
+            <a:endParaRPr lang="en-US" dirty="0"/>
+          </a:p>
+        </p:txBody>
+      </p:sp>
     </p:spTree>
-    <p:extLst>
-      <p:ext uri="{BB962C8B-B14F-4D97-AF65-F5344CB8AC3E}">
-        <p14:creationId xmlns:p14="http://schemas.microsoft.com/office/powerpoint/2010/main" val="1840726560"/>
-      </p:ext>
-    </p:extLst>
   </p:cSld>
   <p:clrMapOvr>
     <a:masterClrMapping/>
@@ -2343,25 +2402,78 @@
       </p:grpSpPr>
       <p:sp>
         <p:nvSpPr>
-          <p:cNvPr id="2" name="Title 1"/>
-          <p:cNvSpPr>
-            <a:spLocks noGrp="1"/>
-          </p:cNvSpPr>
-          <p:nvPr>
-            <p:ph type="title"/>
-          </p:nvPr>
+          <p:cNvPr id="10" name="Plaque 9"/>
+          <p:cNvSpPr/>
+          <p:nvPr/>
         </p:nvSpPr>
         <p:spPr>
           <a:xfrm>
-            <a:off x="1792288" y="4800600"/>
-            <a:ext cx="5486400" cy="566738"/>
+            <a:off x="1950720" y="1847088"/>
+            <a:ext cx="4120896" cy="3090672"/>
+          </a:xfrm>
+          <a:prstGeom prst="plaque">
+            <a:avLst>
+              <a:gd name="adj" fmla="val 8438"/>
+            </a:avLst>
+          </a:prstGeom>
+          <a:noFill/>
+          <a:ln w="9525">
+            <a:solidFill>
+              <a:schemeClr val="tx2">
+                <a:alpha val="17000"/>
+              </a:schemeClr>
+            </a:solidFill>
+            <a:miter lim="800000"/>
+          </a:ln>
+        </p:spPr>
+        <p:style>
+          <a:lnRef idx="2">
+            <a:schemeClr val="accent1">
+              <a:shade val="50000"/>
+            </a:schemeClr>
+          </a:lnRef>
+          <a:fillRef idx="1">
+            <a:schemeClr val="accent1"/>
+          </a:fillRef>
+          <a:effectRef idx="0">
+            <a:schemeClr val="accent1"/>
+          </a:effectRef>
+          <a:fontRef idx="minor">
+            <a:schemeClr val="lt1"/>
+          </a:fontRef>
+        </p:style>
+        <p:txBody>
+          <a:bodyPr rtlCol="0" anchor="ctr"/>
+          <a:lstStyle/>
+          <a:p>
+            <a:pPr algn="ctr"/>
+            <a:endParaRPr lang="en-US"/>
+          </a:p>
+        </p:txBody>
+      </p:sp>
+      <p:sp>
+        <p:nvSpPr>
+          <p:cNvPr id="2" name="Title 1"/>
+          <p:cNvSpPr>
+            <a:spLocks noGrp="1"/>
+          </p:cNvSpPr>
+          <p:nvPr>
+            <p:ph type="title"/>
+          </p:nvPr>
+        </p:nvSpPr>
+        <p:spPr>
+          <a:xfrm>
+            <a:off x="6604000" y="1676400"/>
+            <a:ext cx="3759200" cy="599440"/>
           </a:xfrm>
         </p:spPr>
         <p:txBody>
-          <a:bodyPr anchor="b"/>
+          <a:bodyPr anchor="b">
+            <a:noAutofit/>
+          </a:bodyPr>
           <a:lstStyle>
-            <a:lvl1pPr algn="l">
-              <a:defRPr sz="2000" b="1"/>
+            <a:lvl1pPr algn="ctr">
+              <a:defRPr sz="1700" b="1" cap="all" spc="0" baseline="0"/>
             </a:lvl1pPr>
           </a:lstStyle>
           <a:p>
@@ -2369,7 +2481,7 @@
               <a:rPr lang="en-US" smtClean="0"/>
               <a:t>Click to edit Master title style</a:t>
             </a:r>
-            <a:endParaRPr lang="en-US"/>
+            <a:endParaRPr lang="en-US" dirty="0"/>
           </a:p>
         </p:txBody>
       </p:sp>
@@ -2385,16 +2497,37 @@
         </p:nvSpPr>
         <p:spPr>
           <a:xfrm>
-            <a:off x="1792288" y="612775"/>
-            <a:ext cx="5486400" cy="4114800"/>
+            <a:off x="2032000" y="1905000"/>
+            <a:ext cx="3962400" cy="2971800"/>
           </a:xfrm>
+          <a:prstGeom prst="plaque">
+            <a:avLst>
+              <a:gd name="adj" fmla="val 8341"/>
+            </a:avLst>
+          </a:prstGeom>
+          <a:solidFill>
+            <a:schemeClr val="bg1">
+              <a:lumMod val="95000"/>
+              <a:alpha val="35000"/>
+            </a:schemeClr>
+          </a:solidFill>
+          <a:ln w="98425" cmpd="thinThick">
+            <a:noFill/>
+            <a:bevel/>
+          </a:ln>
         </p:spPr>
         <p:txBody>
-          <a:bodyPr/>
+          <a:bodyPr>
+            <a:normAutofit/>
+          </a:bodyPr>
           <a:lstStyle>
-            <a:lvl1pPr marL="0" indent="0">
-              <a:buNone/>
-              <a:defRPr sz="3200"/>
+            <a:lvl1pPr marL="0" indent="0" algn="ctr">
+              <a:buNone/>
+              <a:defRPr sz="1800" baseline="0">
+                <a:solidFill>
+                  <a:schemeClr val="tx2"/>
+                </a:solidFill>
+              </a:defRPr>
             </a:lvl1pPr>
             <a:lvl2pPr marL="457200" indent="0">
               <a:buNone/>
@@ -2430,7 +2563,11 @@
             </a:lvl9pPr>
           </a:lstStyle>
           <a:p>
-            <a:endParaRPr lang="en-US"/>
+            <a:r>
+              <a:rPr lang="en-US" smtClean="0"/>
+              <a:t>Click icon to add picture</a:t>
+            </a:r>
+            <a:endParaRPr lang="en-US" dirty="0"/>
           </a:p>
         </p:txBody>
       </p:sp>
@@ -2446,14 +2583,14 @@
         </p:nvSpPr>
         <p:spPr>
           <a:xfrm>
-            <a:off x="1792288" y="5367338"/>
-            <a:ext cx="5486400" cy="804862"/>
+            <a:off x="6604000" y="2276856"/>
+            <a:ext cx="3759200" cy="2875280"/>
           </a:xfrm>
         </p:spPr>
         <p:txBody>
           <a:bodyPr/>
           <a:lstStyle>
-            <a:lvl1pPr marL="0" indent="0">
+            <a:lvl1pPr marL="0" indent="0" algn="ctr">
               <a:buNone/>
               <a:defRPr sz="1400"/>
             </a:lvl1pPr>
@@ -2516,7 +2653,7 @@
           <a:p>
             <a:fld id="{5BCAD085-E8A6-8845-BD4E-CB4CCA059FC4}" type="datetimeFigureOut">
               <a:rPr lang="en-US" smtClean="0"/>
-              <a:t>1/27/13</a:t>
+              <a:t>9/18/2026</a:t>
             </a:fld>
             <a:endParaRPr lang="en-US"/>
           </a:p>
@@ -2565,11 +2702,6 @@
         </p:txBody>
       </p:sp>
     </p:spTree>
-    <p:extLst>
-      <p:ext uri="{BB962C8B-B14F-4D97-AF65-F5344CB8AC3E}">
-        <p14:creationId xmlns:p14="http://schemas.microsoft.com/office/powerpoint/2010/main" val="3889236939"/>
-      </p:ext>
-    </p:extLst>
   </p:cSld>
   <p:clrMapOvr>
     <a:masterClrMapping/>
@@ -2599,128 +2731,156 @@
           <a:chExt cx="0" cy="0"/>
         </a:xfrm>
       </p:grpSpPr>
-      <p:sp>
-        <p:nvSpPr>
-          <p:cNvPr id="2" name="Title Placeholder 1"/>
-          <p:cNvSpPr>
-            <a:spLocks noGrp="1"/>
-          </p:cNvSpPr>
-          <p:nvPr>
-            <p:ph type="title"/>
-          </p:nvPr>
-        </p:nvSpPr>
+      <p:pic>
+        <p:nvPicPr>
+          <p:cNvPr id="8" name="Picture 7" descr="window3.png"/>
+          <p:cNvPicPr>
+            <a:picLocks noChangeAspect="1"/>
+          </p:cNvPicPr>
+          <p:nvPr/>
+        </p:nvPicPr>
+        <p:blipFill>
+          <a:blip r:embed="rId13"/>
+          <a:stretch>
+            <a:fillRect/>
+          </a:stretch>
+        </p:blipFill>
         <p:spPr>
           <a:xfrm>
-            <a:off x="457200" y="274638"/>
-            <a:ext cx="8229600" cy="1143000"/>
+            <a:off x="0" y="0"/>
+            <a:ext cx="12192000" cy="6858000"/>
           </a:xfrm>
           <a:prstGeom prst="rect">
             <a:avLst/>
           </a:prstGeom>
         </p:spPr>
-        <p:txBody>
-          <a:bodyPr vert="horz" lIns="91440" tIns="45720" rIns="91440" bIns="45720" rtlCol="0" anchor="ctr">
-            <a:normAutofit/>
-          </a:bodyPr>
-          <a:lstStyle/>
-          <a:p>
-            <a:r>
-              <a:rPr lang="en-US" smtClean="0"/>
-              <a:t>Click to edit Master title style</a:t>
-            </a:r>
-            <a:endParaRPr lang="en-US"/>
-          </a:p>
-        </p:txBody>
-      </p:sp>
-      <p:sp>
-        <p:nvSpPr>
-          <p:cNvPr id="3" name="Text Placeholder 2"/>
-          <p:cNvSpPr>
-            <a:spLocks noGrp="1"/>
-          </p:cNvSpPr>
-          <p:nvPr>
-            <p:ph type="body" idx="1"/>
+      </p:pic>
+      <p:sp>
+        <p:nvSpPr>
+          <p:cNvPr id="2" name="Title Placeholder 1"/>
+          <p:cNvSpPr>
+            <a:spLocks noGrp="1"/>
+          </p:cNvSpPr>
+          <p:nvPr>
+            <p:ph type="title"/>
           </p:nvPr>
         </p:nvSpPr>
         <p:spPr>
           <a:xfrm>
-            <a:off x="457200" y="1600200"/>
-            <a:ext cx="8229600" cy="4525963"/>
+            <a:off x="1828800" y="1295400"/>
+            <a:ext cx="8534400" cy="685800"/>
           </a:xfrm>
           <a:prstGeom prst="rect">
             <a:avLst/>
           </a:prstGeom>
         </p:spPr>
         <p:txBody>
-          <a:bodyPr vert="horz" lIns="91440" tIns="45720" rIns="91440" bIns="45720" rtlCol="0">
+          <a:bodyPr vert="horz" lIns="91440" tIns="45720" rIns="91440" bIns="45720" rtlCol="0" anchor="b" anchorCtr="0">
             <a:normAutofit/>
           </a:bodyPr>
           <a:lstStyle/>
           <a:p>
-            <a:pPr lvl="0"/>
-            <a:r>
-              <a:rPr lang="en-US" smtClean="0"/>
-              <a:t>Click to edit Master text styles</a:t>
-            </a:r>
-          </a:p>
-          <a:p>
-            <a:pPr lvl="1"/>
-            <a:r>
-              <a:rPr lang="en-US" smtClean="0"/>
-              <a:t>Second level</a:t>
-            </a:r>
-          </a:p>
-          <a:p>
-            <a:pPr lvl="2"/>
-            <a:r>
-              <a:rPr lang="en-US" smtClean="0"/>
-              <a:t>Third level</a:t>
-            </a:r>
-          </a:p>
-          <a:p>
-            <a:pPr lvl="3"/>
-            <a:r>
-              <a:rPr lang="en-US" smtClean="0"/>
-              <a:t>Fourth level</a:t>
-            </a:r>
-          </a:p>
-          <a:p>
-            <a:pPr lvl="4"/>
-            <a:r>
-              <a:rPr lang="en-US" smtClean="0"/>
-              <a:t>Fifth level</a:t>
-            </a:r>
-            <a:endParaRPr lang="en-US"/>
-          </a:p>
-        </p:txBody>
-      </p:sp>
-      <p:sp>
-        <p:nvSpPr>
-          <p:cNvPr id="4" name="Date Placeholder 3"/>
-          <p:cNvSpPr>
-            <a:spLocks noGrp="1"/>
-          </p:cNvSpPr>
-          <p:nvPr>
-            <p:ph type="dt" sz="half" idx="2"/>
+            <a:r>
+              <a:rPr lang="en-US" smtClean="0"/>
+              <a:t>Click to edit Master title style</a:t>
+            </a:r>
+            <a:endParaRPr lang="en-US" dirty="0"/>
+          </a:p>
+        </p:txBody>
+      </p:sp>
+      <p:sp>
+        <p:nvSpPr>
+          <p:cNvPr id="3" name="Text Placeholder 2"/>
+          <p:cNvSpPr>
+            <a:spLocks noGrp="1"/>
+          </p:cNvSpPr>
+          <p:nvPr>
+            <p:ph type="body" idx="1"/>
           </p:nvPr>
         </p:nvSpPr>
         <p:spPr>
           <a:xfrm>
-            <a:off x="457200" y="6356350"/>
-            <a:ext cx="2133600" cy="365125"/>
+            <a:off x="1828800" y="2057401"/>
+            <a:ext cx="8534400" cy="3429001"/>
           </a:xfrm>
           <a:prstGeom prst="rect">
             <a:avLst/>
           </a:prstGeom>
         </p:spPr>
         <p:txBody>
+          <a:bodyPr vert="horz" lIns="91440" tIns="45720" rIns="91440" bIns="45720" rtlCol="0">
+            <a:normAutofit/>
+          </a:bodyPr>
+          <a:lstStyle/>
+          <a:p>
+            <a:pPr lvl="0"/>
+            <a:r>
+              <a:rPr lang="en-US" smtClean="0"/>
+              <a:t>Click to edit Master text styles</a:t>
+            </a:r>
+          </a:p>
+          <a:p>
+            <a:pPr lvl="1"/>
+            <a:r>
+              <a:rPr lang="en-US" smtClean="0"/>
+              <a:t>Second level</a:t>
+            </a:r>
+          </a:p>
+          <a:p>
+            <a:pPr lvl="2"/>
+            <a:r>
+              <a:rPr lang="en-US" smtClean="0"/>
+              <a:t>Third level</a:t>
+            </a:r>
+          </a:p>
+          <a:p>
+            <a:pPr lvl="3"/>
+            <a:r>
+              <a:rPr lang="en-US" smtClean="0"/>
+              <a:t>Fourth level</a:t>
+            </a:r>
+          </a:p>
+          <a:p>
+            <a:pPr lvl="4"/>
+            <a:r>
+              <a:rPr lang="en-US" smtClean="0"/>
+              <a:t>Fifth level</a:t>
+            </a:r>
+            <a:endParaRPr lang="en-US" dirty="0"/>
+          </a:p>
+        </p:txBody>
+      </p:sp>
+      <p:sp>
+        <p:nvSpPr>
+          <p:cNvPr id="4" name="Date Placeholder 3"/>
+          <p:cNvSpPr>
+            <a:spLocks noGrp="1"/>
+          </p:cNvSpPr>
+          <p:nvPr>
+            <p:ph type="dt" sz="half" idx="2"/>
+          </p:nvPr>
+        </p:nvSpPr>
+        <p:spPr bwMode="white">
+          <a:xfrm>
+            <a:off x="406400" y="6356351"/>
+            <a:ext cx="2844800" cy="365125"/>
+          </a:xfrm>
+          <a:prstGeom prst="rect">
+            <a:avLst/>
+          </a:prstGeom>
+          <a:ln>
+            <a:noFill/>
+          </a:ln>
+        </p:spPr>
+        <p:txBody>
           <a:bodyPr vert="horz" lIns="91440" tIns="45720" rIns="91440" bIns="45720" rtlCol="0" anchor="ctr"/>
           <a:lstStyle>
             <a:lvl1pPr algn="l">
-              <a:defRPr sz="1200">
-                <a:solidFill>
-                  <a:schemeClr val="tx1">
-                    <a:tint val="75000"/>
+              <a:defRPr sz="1100" baseline="0">
+                <a:solidFill>
+                  <a:schemeClr val="accent1">
+                    <a:lumMod val="60000"/>
+                    <a:lumOff val="40000"/>
                   </a:schemeClr>
                 </a:solidFill>
               </a:defRPr>
@@ -2729,7 +2889,7 @@
           <a:p>
             <a:fld id="{5BCAD085-E8A6-8845-BD4E-CB4CCA059FC4}" type="datetimeFigureOut">
               <a:rPr lang="en-US" smtClean="0"/>
-              <a:t>1/27/13</a:t>
+              <a:t>9/18/2026</a:t>
             </a:fld>
             <a:endParaRPr lang="en-US"/>
           </a:p>
@@ -2745,10 +2905,10 @@
             <p:ph type="ftr" sz="quarter" idx="3"/>
           </p:nvPr>
         </p:nvSpPr>
-        <p:spPr>
+        <p:spPr bwMode="white">
           <a:xfrm>
-            <a:off x="3124200" y="6356350"/>
-            <a:ext cx="2895600" cy="365125"/>
+            <a:off x="3962400" y="6356351"/>
+            <a:ext cx="4267200" cy="365125"/>
           </a:xfrm>
           <a:prstGeom prst="rect">
             <a:avLst/>
@@ -2758,10 +2918,11 @@
           <a:bodyPr vert="horz" lIns="91440" tIns="45720" rIns="91440" bIns="45720" rtlCol="0" anchor="ctr"/>
           <a:lstStyle>
             <a:lvl1pPr algn="ctr">
-              <a:defRPr sz="1200">
-                <a:solidFill>
-                  <a:schemeClr val="tx1">
-                    <a:tint val="75000"/>
+              <a:defRPr sz="1100" baseline="0">
+                <a:solidFill>
+                  <a:schemeClr val="accent1">
+                    <a:lumMod val="60000"/>
+                    <a:lumOff val="40000"/>
                   </a:schemeClr>
                 </a:solidFill>
               </a:defRPr>
@@ -2782,10 +2943,10 @@
             <p:ph type="sldNum" sz="quarter" idx="4"/>
           </p:nvPr>
         </p:nvSpPr>
-        <p:spPr>
+        <p:spPr bwMode="white">
           <a:xfrm>
-            <a:off x="6553200" y="6356350"/>
-            <a:ext cx="2133600" cy="365125"/>
+            <a:off x="8900160" y="6364225"/>
+            <a:ext cx="2844800" cy="365125"/>
           </a:xfrm>
           <a:prstGeom prst="rect">
             <a:avLst/>
@@ -2795,10 +2956,11 @@
           <a:bodyPr vert="horz" lIns="91440" tIns="45720" rIns="91440" bIns="45720" rtlCol="0" anchor="ctr"/>
           <a:lstStyle>
             <a:lvl1pPr algn="r">
-              <a:defRPr sz="1200">
-                <a:solidFill>
-                  <a:schemeClr val="tx1">
-                    <a:tint val="75000"/>
+              <a:defRPr sz="1200" b="1" baseline="0">
+                <a:solidFill>
+                  <a:schemeClr val="accent1">
+                    <a:lumMod val="60000"/>
+                    <a:lumOff val="40000"/>
                   </a:schemeClr>
                 </a:solidFill>
               </a:defRPr>
@@ -2814,34 +2976,29 @@
         </p:txBody>
       </p:sp>
     </p:spTree>
-    <p:extLst>
-      <p:ext uri="{BB962C8B-B14F-4D97-AF65-F5344CB8AC3E}">
-        <p14:creationId xmlns:p14="http://schemas.microsoft.com/office/powerpoint/2010/main" val="2209977519"/>
-      </p:ext>
-    </p:extLst>
   </p:cSld>
   <p:clrMap bg1="lt1" tx1="dk1" bg2="lt2" tx2="dk2" accent1="accent1" accent2="accent2" accent3="accent3" accent4="accent4" accent5="accent5" accent6="accent6" hlink="hlink" folHlink="folHlink"/>
   <p:sldLayoutIdLst>
-    <p:sldLayoutId id="2147483649" r:id="rId1"/>
-    <p:sldLayoutId id="2147483650" r:id="rId2"/>
-    <p:sldLayoutId id="2147483651" r:id="rId3"/>
-    <p:sldLayoutId id="2147483652" r:id="rId4"/>
-    <p:sldLayoutId id="2147483653" r:id="rId5"/>
-    <p:sldLayoutId id="2147483654" r:id="rId6"/>
-    <p:sldLayoutId id="2147483655" r:id="rId7"/>
-    <p:sldLayoutId id="2147483656" r:id="rId8"/>
-    <p:sldLayoutId id="2147483657" r:id="rId9"/>
-    <p:sldLayoutId id="2147483658" r:id="rId10"/>
-    <p:sldLayoutId id="2147483659" r:id="rId11"/>
+    <p:sldLayoutId id="2147483781" r:id="rId1"/>
+    <p:sldLayoutId id="2147483782" r:id="rId2"/>
+    <p:sldLayoutId id="2147483783" r:id="rId3"/>
+    <p:sldLayoutId id="2147483784" r:id="rId4"/>
+    <p:sldLayoutId id="2147483785" r:id="rId5"/>
+    <p:sldLayoutId id="2147483786" r:id="rId6"/>
+    <p:sldLayoutId id="2147483787" r:id="rId7"/>
+    <p:sldLayoutId id="2147483788" r:id="rId8"/>
+    <p:sldLayoutId id="2147483789" r:id="rId9"/>
+    <p:sldLayoutId id="2147483790" r:id="rId10"/>
+    <p:sldLayoutId id="2147483791" r:id="rId11"/>
   </p:sldLayoutIdLst>
   <p:txStyles>
     <p:titleStyle>
-      <a:lvl1pPr algn="ctr" defTabSz="457200" rtl="0" eaLnBrk="1" latinLnBrk="0" hangingPunct="1">
+      <a:lvl1pPr algn="ctr" defTabSz="914400" rtl="0" eaLnBrk="1" latinLnBrk="0" hangingPunct="1">
         <a:spcBef>
           <a:spcPct val="0"/>
         </a:spcBef>
         <a:buNone/>
-        <a:defRPr sz="4400" kern="1200">
+        <a:defRPr sz="3600" kern="1200" cap="all" spc="300" baseline="0">
           <a:solidFill>
             <a:schemeClr val="tx1"/>
           </a:solidFill>
@@ -2850,15 +3007,75 @@
           <a:cs typeface="+mj-cs"/>
         </a:defRPr>
       </a:lvl1pPr>
+      <a:lvl2pPr eaLnBrk="1" hangingPunct="1">
+        <a:defRPr>
+          <a:solidFill>
+            <a:schemeClr val="tx2"/>
+          </a:solidFill>
+        </a:defRPr>
+      </a:lvl2pPr>
+      <a:lvl3pPr eaLnBrk="1" hangingPunct="1">
+        <a:defRPr>
+          <a:solidFill>
+            <a:schemeClr val="tx2"/>
+          </a:solidFill>
+        </a:defRPr>
+      </a:lvl3pPr>
+      <a:lvl4pPr eaLnBrk="1" hangingPunct="1">
+        <a:defRPr>
+          <a:solidFill>
+            <a:schemeClr val="tx2"/>
+          </a:solidFill>
+        </a:defRPr>
+      </a:lvl4pPr>
+      <a:lvl5pPr eaLnBrk="1" hangingPunct="1">
+        <a:defRPr>
+          <a:solidFill>
+            <a:schemeClr val="tx2"/>
+          </a:solidFill>
+        </a:defRPr>
+      </a:lvl5pPr>
+      <a:lvl6pPr eaLnBrk="1" hangingPunct="1">
+        <a:defRPr>
+          <a:solidFill>
+            <a:schemeClr val="tx2"/>
+          </a:solidFill>
+        </a:defRPr>
+      </a:lvl6pPr>
+      <a:lvl7pPr eaLnBrk="1" hangingPunct="1">
+        <a:defRPr>
+          <a:solidFill>
+            <a:schemeClr val="tx2"/>
+          </a:solidFill>
+        </a:defRPr>
+      </a:lvl7pPr>
+      <a:lvl8pPr eaLnBrk="1" hangingPunct="1">
+        <a:defRPr>
+          <a:solidFill>
+            <a:schemeClr val="tx2"/>
+          </a:solidFill>
+        </a:defRPr>
+      </a:lvl8pPr>
+      <a:lvl9pPr eaLnBrk="1" hangingPunct="1">
+        <a:defRPr>
+          <a:solidFill>
+            <a:schemeClr val="tx2"/>
+          </a:solidFill>
+        </a:defRPr>
+      </a:lvl9pPr>
     </p:titleStyle>
     <p:bodyStyle>
-      <a:lvl1pPr marL="342900" indent="-342900" algn="l" defTabSz="457200" rtl="0" eaLnBrk="1" latinLnBrk="0" hangingPunct="1">
+      <a:lvl1pPr marL="0" indent="-274320" algn="l" defTabSz="914400" rtl="0" eaLnBrk="1" latinLnBrk="0" hangingPunct="1">
+        <a:lnSpc>
+          <a:spcPct val="150000"/>
+        </a:lnSpc>
         <a:spcBef>
           <a:spcPct val="20000"/>
         </a:spcBef>
-        <a:buFont typeface="Arial"/>
-        <a:buChar char="•"/>
-        <a:defRPr sz="3200" kern="1200">
+        <a:buClrTx/>
+        <a:buFont typeface="Wingdings" pitchFamily="2" charset="2"/>
+        <a:buChar char="v"/>
+        <a:defRPr sz="1800" kern="1200" baseline="0">
           <a:solidFill>
             <a:schemeClr val="tx1"/>
           </a:solidFill>
@@ -2867,13 +3084,14 @@
           <a:cs typeface="+mn-cs"/>
         </a:defRPr>
       </a:lvl1pPr>
-      <a:lvl2pPr marL="742950" indent="-285750" algn="l" defTabSz="457200" rtl="0" eaLnBrk="1" latinLnBrk="0" hangingPunct="1">
+      <a:lvl2pPr marL="742950" indent="-228600" algn="l" defTabSz="914400" rtl="0" eaLnBrk="1" latinLnBrk="0" hangingPunct="1">
         <a:spcBef>
           <a:spcPct val="20000"/>
         </a:spcBef>
-        <a:buFont typeface="Arial"/>
-        <a:buChar char="–"/>
-        <a:defRPr sz="2800" kern="1200">
+        <a:buClrTx/>
+        <a:buFont typeface="Arial" pitchFamily="34" charset="0"/>
+        <a:buChar char="•"/>
+        <a:defRPr sz="1600" kern="1200" baseline="0">
           <a:solidFill>
             <a:schemeClr val="tx1"/>
           </a:solidFill>
@@ -2882,13 +3100,14 @@
           <a:cs typeface="+mn-cs"/>
         </a:defRPr>
       </a:lvl2pPr>
-      <a:lvl3pPr marL="1143000" indent="-228600" algn="l" defTabSz="457200" rtl="0" eaLnBrk="1" latinLnBrk="0" hangingPunct="1">
+      <a:lvl3pPr marL="1143000" indent="-228600" algn="l" defTabSz="914400" rtl="0" eaLnBrk="1" latinLnBrk="0" hangingPunct="1">
         <a:spcBef>
           <a:spcPct val="20000"/>
         </a:spcBef>
-        <a:buFont typeface="Arial"/>
+        <a:buClrTx/>
+        <a:buFont typeface="Arial" pitchFamily="34" charset="0"/>
         <a:buChar char="•"/>
-        <a:defRPr sz="2400" kern="1200">
+        <a:defRPr sz="1400" kern="1200" baseline="0">
           <a:solidFill>
             <a:schemeClr val="tx1"/>
           </a:solidFill>
@@ -2897,13 +3116,14 @@
           <a:cs typeface="+mn-cs"/>
         </a:defRPr>
       </a:lvl3pPr>
-      <a:lvl4pPr marL="1600200" indent="-228600" algn="l" defTabSz="457200" rtl="0" eaLnBrk="1" latinLnBrk="0" hangingPunct="1">
+      <a:lvl4pPr marL="1600200" indent="-228600" algn="l" defTabSz="914400" rtl="0" eaLnBrk="1" latinLnBrk="0" hangingPunct="1">
         <a:spcBef>
           <a:spcPct val="20000"/>
         </a:spcBef>
-        <a:buFont typeface="Arial"/>
-        <a:buChar char="–"/>
-        <a:defRPr sz="2000" kern="1200">
+        <a:buClrTx/>
+        <a:buFont typeface="Arial" pitchFamily="34" charset="0"/>
+        <a:buChar char="•"/>
+        <a:defRPr sz="1400" kern="1200" baseline="0">
           <a:solidFill>
             <a:schemeClr val="tx1"/>
           </a:solidFill>
@@ -2912,13 +3132,14 @@
           <a:cs typeface="+mn-cs"/>
         </a:defRPr>
       </a:lvl4pPr>
-      <a:lvl5pPr marL="2057400" indent="-228600" algn="l" defTabSz="457200" rtl="0" eaLnBrk="1" latinLnBrk="0" hangingPunct="1">
+      <a:lvl5pPr marL="2057400" indent="-228600" algn="l" defTabSz="914400" rtl="0" eaLnBrk="1" latinLnBrk="0" hangingPunct="1">
         <a:spcBef>
           <a:spcPct val="20000"/>
         </a:spcBef>
-        <a:buFont typeface="Arial"/>
-        <a:buChar char="»"/>
-        <a:defRPr sz="2000" kern="1200">
+        <a:buClrTx/>
+        <a:buFont typeface="Arial" pitchFamily="34" charset="0"/>
+        <a:buChar char="•"/>
+        <a:defRPr sz="1400" kern="1200" baseline="0">
           <a:solidFill>
             <a:schemeClr val="tx1"/>
           </a:solidFill>
@@ -2927,13 +3148,14 @@
           <a:cs typeface="+mn-cs"/>
         </a:defRPr>
       </a:lvl5pPr>
-      <a:lvl6pPr marL="2514600" indent="-228600" algn="l" defTabSz="457200" rtl="0" eaLnBrk="1" latinLnBrk="0" hangingPunct="1">
+      <a:lvl6pPr marL="2514600" indent="-228600" algn="l" defTabSz="914400" rtl="0" eaLnBrk="1" latinLnBrk="0" hangingPunct="1">
         <a:spcBef>
           <a:spcPct val="20000"/>
         </a:spcBef>
-        <a:buFont typeface="Arial"/>
+        <a:buClrTx/>
+        <a:buFont typeface="Arial" pitchFamily="34" charset="0"/>
         <a:buChar char="•"/>
-        <a:defRPr sz="2000" kern="1200">
+        <a:defRPr sz="1400" kern="1200">
           <a:solidFill>
             <a:schemeClr val="tx1"/>
           </a:solidFill>
@@ -2942,13 +3164,14 @@
           <a:cs typeface="+mn-cs"/>
         </a:defRPr>
       </a:lvl6pPr>
-      <a:lvl7pPr marL="2971800" indent="-228600" algn="l" defTabSz="457200" rtl="0" eaLnBrk="1" latinLnBrk="0" hangingPunct="1">
+      <a:lvl7pPr marL="2971800" indent="-228600" algn="l" defTabSz="914400" rtl="0" eaLnBrk="1" latinLnBrk="0" hangingPunct="1">
         <a:spcBef>
           <a:spcPct val="20000"/>
         </a:spcBef>
-        <a:buFont typeface="Arial"/>
+        <a:buClrTx/>
+        <a:buFont typeface="Arial" pitchFamily="34" charset="0"/>
         <a:buChar char="•"/>
-        <a:defRPr sz="2000" kern="1200">
+        <a:defRPr sz="1200" kern="1200">
           <a:solidFill>
             <a:schemeClr val="tx1"/>
           </a:solidFill>
@@ -2957,13 +3180,14 @@
           <a:cs typeface="+mn-cs"/>
         </a:defRPr>
       </a:lvl7pPr>
-      <a:lvl8pPr marL="3429000" indent="-228600" algn="l" defTabSz="457200" rtl="0" eaLnBrk="1" latinLnBrk="0" hangingPunct="1">
+      <a:lvl8pPr marL="3429000" indent="-228600" algn="l" defTabSz="914400" rtl="0" eaLnBrk="1" latinLnBrk="0" hangingPunct="1">
         <a:spcBef>
           <a:spcPct val="20000"/>
         </a:spcBef>
-        <a:buFont typeface="Arial"/>
+        <a:buClrTx/>
+        <a:buFont typeface="Arial" pitchFamily="34" charset="0"/>
         <a:buChar char="•"/>
-        <a:defRPr sz="2000" kern="1200">
+        <a:defRPr sz="1200" kern="1200" baseline="0">
           <a:solidFill>
             <a:schemeClr val="tx1"/>
           </a:solidFill>
@@ -2972,13 +3196,14 @@
           <a:cs typeface="+mn-cs"/>
         </a:defRPr>
       </a:lvl8pPr>
-      <a:lvl9pPr marL="3886200" indent="-228600" algn="l" defTabSz="457200" rtl="0" eaLnBrk="1" latinLnBrk="0" hangingPunct="1">
+      <a:lvl9pPr marL="3886200" indent="-228600" algn="l" defTabSz="914400" rtl="0" eaLnBrk="1" latinLnBrk="0" hangingPunct="1">
         <a:spcBef>
           <a:spcPct val="20000"/>
         </a:spcBef>
-        <a:buFont typeface="Arial"/>
+        <a:buClrTx/>
+        <a:buFont typeface="Arial" pitchFamily="34" charset="0"/>
         <a:buChar char="•"/>
-        <a:defRPr sz="2000" kern="1200">
+        <a:defRPr sz="1200" kern="1200">
           <a:solidFill>
             <a:schemeClr val="tx1"/>
           </a:solidFill>
@@ -2992,7 +3217,7 @@
       <a:defPPr>
         <a:defRPr lang="en-US"/>
       </a:defPPr>
-      <a:lvl1pPr marL="0" algn="l" defTabSz="457200" rtl="0" eaLnBrk="1" latinLnBrk="0" hangingPunct="1">
+      <a:lvl1pPr marL="0" algn="l" defTabSz="914400" rtl="0" eaLnBrk="1" latinLnBrk="0" hangingPunct="1">
         <a:defRPr sz="1800" kern="1200">
           <a:solidFill>
             <a:schemeClr val="tx1"/>
@@ -3002,7 +3227,7 @@
           <a:cs typeface="+mn-cs"/>
         </a:defRPr>
       </a:lvl1pPr>
-      <a:lvl2pPr marL="457200" algn="l" defTabSz="457200" rtl="0" eaLnBrk="1" latinLnBrk="0" hangingPunct="1">
+      <a:lvl2pPr marL="457200" algn="l" defTabSz="914400" rtl="0" eaLnBrk="1" latinLnBrk="0" hangingPunct="1">
         <a:defRPr sz="1800" kern="1200">
           <a:solidFill>
             <a:schemeClr val="tx1"/>
@@ -3012,7 +3237,7 @@
           <a:cs typeface="+mn-cs"/>
         </a:defRPr>
       </a:lvl2pPr>
-      <a:lvl3pPr marL="914400" algn="l" defTabSz="457200" rtl="0" eaLnBrk="1" latinLnBrk="0" hangingPunct="1">
+      <a:lvl3pPr marL="914400" algn="l" defTabSz="914400" rtl="0" eaLnBrk="1" latinLnBrk="0" hangingPunct="1">
         <a:defRPr sz="1800" kern="1200">
           <a:solidFill>
             <a:schemeClr val="tx1"/>
@@ -3022,7 +3247,7 @@
           <a:cs typeface="+mn-cs"/>
         </a:defRPr>
       </a:lvl3pPr>
-      <a:lvl4pPr marL="1371600" algn="l" defTabSz="457200" rtl="0" eaLnBrk="1" latinLnBrk="0" hangingPunct="1">
+      <a:lvl4pPr marL="1371600" algn="l" defTabSz="914400" rtl="0" eaLnBrk="1" latinLnBrk="0" hangingPunct="1">
         <a:defRPr sz="1800" kern="1200">
           <a:solidFill>
             <a:schemeClr val="tx1"/>
@@ -3032,7 +3257,7 @@
           <a:cs typeface="+mn-cs"/>
         </a:defRPr>
       </a:lvl4pPr>
-      <a:lvl5pPr marL="1828800" algn="l" defTabSz="457200" rtl="0" eaLnBrk="1" latinLnBrk="0" hangingPunct="1">
+      <a:lvl5pPr marL="1828800" algn="l" defTabSz="914400" rtl="0" eaLnBrk="1" latinLnBrk="0" hangingPunct="1">
         <a:defRPr sz="1800" kern="1200">
           <a:solidFill>
             <a:schemeClr val="tx1"/>
@@ -3042,7 +3267,7 @@
           <a:cs typeface="+mn-cs"/>
         </a:defRPr>
       </a:lvl5pPr>
-      <a:lvl6pPr marL="2286000" algn="l" defTabSz="457200" rtl="0" eaLnBrk="1" latinLnBrk="0" hangingPunct="1">
+      <a:lvl6pPr marL="2286000" algn="l" defTabSz="914400" rtl="0" eaLnBrk="1" latinLnBrk="0" hangingPunct="1">
         <a:defRPr sz="1800" kern="1200">
           <a:solidFill>
             <a:schemeClr val="tx1"/>
@@ -3052,7 +3277,7 @@
           <a:cs typeface="+mn-cs"/>
         </a:defRPr>
       </a:lvl6pPr>
-      <a:lvl7pPr marL="2743200" algn="l" defTabSz="457200" rtl="0" eaLnBrk="1" latinLnBrk="0" hangingPunct="1">
+      <a:lvl7pPr marL="2743200" algn="l" defTabSz="914400" rtl="0" eaLnBrk="1" latinLnBrk="0" hangingPunct="1">
         <a:defRPr sz="1800" kern="1200">
           <a:solidFill>
             <a:schemeClr val="tx1"/>
@@ -3062,7 +3287,7 @@
           <a:cs typeface="+mn-cs"/>
         </a:defRPr>
       </a:lvl7pPr>
-      <a:lvl8pPr marL="3200400" algn="l" defTabSz="457200" rtl="0" eaLnBrk="1" latinLnBrk="0" hangingPunct="1">
+      <a:lvl8pPr marL="3200400" algn="l" defTabSz="914400" rtl="0" eaLnBrk="1" latinLnBrk="0" hangingPunct="1">
         <a:defRPr sz="1800" kern="1200">
           <a:solidFill>
             <a:schemeClr val="tx1"/>
@@ -3072,7 +3297,7 @@
           <a:cs typeface="+mn-cs"/>
         </a:defRPr>
       </a:lvl8pPr>
-      <a:lvl9pPr marL="3657600" algn="l" defTabSz="457200" rtl="0" eaLnBrk="1" latinLnBrk="0" hangingPunct="1">
+      <a:lvl9pPr marL="3657600" algn="l" defTabSz="914400" rtl="0" eaLnBrk="1" latinLnBrk="0" hangingPunct="1">
         <a:defRPr sz="1800" kern="1200">
           <a:solidFill>
             <a:schemeClr val="tx1"/>
@@ -3088,7 +3313,7 @@
 </file>
 
 <file path=ppt/slides/slide1.xml><?xml version="1.0" encoding="utf-8"?>
-<p:sld xmlns:a="http://schemas.openxmlformats.org/drawingml/2006/main" xmlns:p="http://schemas.openxmlformats.org/presentationml/2006/main" xmlns:r="http://schemas.openxmlformats.org/officeDocument/2006/relationships">
+<p:sld xmlns:a="http://schemas.openxmlformats.org/drawingml/2006/main" xmlns:r="http://schemas.openxmlformats.org/officeDocument/2006/relationships" xmlns:p="http://schemas.openxmlformats.org/presentationml/2006/main">
   <p:cSld>
     <p:spTree>
       <p:nvGrpSpPr>
@@ -3096,7 +3321,14 @@
         <p:cNvGrpSpPr/>
         <p:nvPr/>
       </p:nvGrpSpPr>
-      <p:grpSpPr/>
+      <p:grpSpPr>
+        <a:xfrm>
+          <a:off x="0" y="0"/>
+          <a:ext cx="0" cy="0"/>
+          <a:chOff x="0" y="0"/>
+          <a:chExt cx="0" cy="0"/>
+        </a:xfrm>
+      </p:grpSpPr>
       <p:sp>
         <p:nvSpPr>
           <p:cNvPr id="2" name="Rectangle 1"/>
@@ -3105,7 +3337,7 @@
         </p:nvSpPr>
         <p:spPr>
           <a:xfrm>
-            <a:off x="0" y="0"/>
+            <a:off x="2" y="0"/>
             <a:ext cx="12191695" cy="6858000"/>
           </a:xfrm>
           <a:prstGeom prst="rect">
@@ -3137,6 +3369,7 @@
           <a:lstStyle/>
           <a:p>
             <a:pPr algn="ctr"/>
+            <a:endParaRPr/>
           </a:p>
         </p:txBody>
       </p:sp>
@@ -3200,8 +3433,8 @@
         </p:nvSpPr>
         <p:spPr>
           <a:xfrm>
-            <a:off x="914400" y="1234440"/>
-            <a:ext cx="10362895" cy="2011680"/>
+            <a:off x="914402" y="1234441"/>
+            <a:ext cx="10362895" cy="1154162"/>
           </a:xfrm>
           <a:prstGeom prst="rect">
             <a:avLst/>
@@ -3289,7 +3522,7 @@
           </a:fontRef>
         </p:style>
         <p:txBody>
-          <a:bodyPr rtlCol="0" anchor="ctr" wrap="square" lIns="182880" rIns="182880" tIns="182880"/>
+          <a:bodyPr wrap="square" lIns="182880" tIns="182880" rIns="182880" rtlCol="0" anchor="ctr"/>
           <a:lstStyle/>
           <a:p>
             <a:pPr algn="ctr">
@@ -3304,14 +3537,10 @@
             </a:r>
           </a:p>
           <a:p>
+            <a:r>
+              <a:t/>
+            </a:r>
             <a:br/>
-            <a:pPr>
-              <a:defRPr sz="1100">
-                <a:solidFill>
-                  <a:srgbClr val="FFFFFF"/>
-                </a:solidFill>
-              </a:defRPr>
-            </a:pPr>
             <a:r>
               <a:t>Deterministic Python rules engine executing 100% grounded policy decisions, delay vouchers, &amp; ₹1,500 supervisor waiver limits.</a:t>
             </a:r>
@@ -3356,7 +3585,7 @@
           </a:fontRef>
         </p:style>
         <p:txBody>
-          <a:bodyPr rtlCol="0" anchor="ctr" wrap="square" lIns="182880" rIns="182880" tIns="182880"/>
+          <a:bodyPr wrap="square" lIns="182880" tIns="182880" rIns="182880" rtlCol="0" anchor="ctr"/>
           <a:lstStyle/>
           <a:p>
             <a:pPr algn="ctr">
@@ -3371,14 +3600,10 @@
             </a:r>
           </a:p>
           <a:p>
+            <a:r>
+              <a:t/>
+            </a:r>
             <a:br/>
-            <a:pPr>
-              <a:defRPr sz="1100">
-                <a:solidFill>
-                  <a:srgbClr val="FFFFFF"/>
-                </a:solidFill>
-              </a:defRPr>
-            </a:pPr>
             <a:r>
               <a:t>End-to-end resolution for Priya Nair (Gold), Arvind Kulkarni (Silver), &amp; Meher Kaur (Platinum) with escalation handling.</a:t>
             </a:r>
@@ -3423,7 +3648,7 @@
           </a:fontRef>
         </p:style>
         <p:txBody>
-          <a:bodyPr rtlCol="0" anchor="ctr" wrap="square" lIns="182880" rIns="182880" tIns="182880"/>
+          <a:bodyPr wrap="square" lIns="182880" tIns="182880" rIns="182880" rtlCol="0" anchor="ctr"/>
           <a:lstStyle/>
           <a:p>
             <a:pPr algn="ctr">
@@ -3438,14 +3663,10 @@
             </a:r>
           </a:p>
           <a:p>
+            <a:r>
+              <a:t/>
+            </a:r>
             <a:br/>
-            <a:pPr>
-              <a:defRPr sz="1100">
-                <a:solidFill>
-                  <a:srgbClr val="FFFFFF"/>
-                </a:solidFill>
-              </a:defRPr>
-            </a:pPr>
             <a:r>
               <a:t>Multi-Language (English &lt;-&gt; हिन्दी), Instant 1-tap Passenger Switcher, and Official Downloadable PDF Claim Receipts.</a:t>
             </a:r>
@@ -3460,7 +3681,7 @@
         </p:nvSpPr>
         <p:spPr>
           <a:xfrm>
-            <a:off x="914400" y="5715000"/>
+            <a:off x="914402" y="5715000"/>
             <a:ext cx="10362895" cy="594360"/>
           </a:xfrm>
           <a:prstGeom prst="rect">
@@ -3490,7 +3711,7 @@
           </a:fontRef>
         </p:style>
         <p:txBody>
-          <a:bodyPr rtlCol="0" anchor="ctr" wrap="square"/>
+          <a:bodyPr wrap="square" rtlCol="0" anchor="ctr"/>
           <a:lstStyle/>
           <a:p>
             <a:pPr algn="ctr">
@@ -3515,7 +3736,7 @@
 </file>
 
 <file path=ppt/slides/slide10.xml><?xml version="1.0" encoding="utf-8"?>
-<p:sld xmlns:a="http://schemas.openxmlformats.org/drawingml/2006/main" xmlns:p="http://schemas.openxmlformats.org/presentationml/2006/main" xmlns:r="http://schemas.openxmlformats.org/officeDocument/2006/relationships">
+<p:sld xmlns:a="http://schemas.openxmlformats.org/drawingml/2006/main" xmlns:r="http://schemas.openxmlformats.org/officeDocument/2006/relationships" xmlns:p="http://schemas.openxmlformats.org/presentationml/2006/main">
   <p:cSld>
     <p:spTree>
       <p:nvGrpSpPr>
@@ -3523,7 +3744,14 @@
         <p:cNvGrpSpPr/>
         <p:nvPr/>
       </p:nvGrpSpPr>
-      <p:grpSpPr/>
+      <p:grpSpPr>
+        <a:xfrm>
+          <a:off x="0" y="0"/>
+          <a:ext cx="0" cy="0"/>
+          <a:chOff x="0" y="0"/>
+          <a:chExt cx="0" cy="0"/>
+        </a:xfrm>
+      </p:grpSpPr>
       <p:sp>
         <p:nvSpPr>
           <p:cNvPr id="2" name="Rectangle 1"/>
@@ -3532,7 +3760,7 @@
         </p:nvSpPr>
         <p:spPr>
           <a:xfrm>
-            <a:off x="731520" y="457200"/>
+            <a:off x="731522" y="457200"/>
             <a:ext cx="10728655" cy="1005840"/>
           </a:xfrm>
           <a:prstGeom prst="rect">
@@ -3562,7 +3790,7 @@
           </a:fontRef>
         </p:style>
         <p:txBody>
-          <a:bodyPr rtlCol="0" anchor="ctr" wrap="square" lIns="274320" tIns="137160"/>
+          <a:bodyPr wrap="square" lIns="274320" tIns="137160" rtlCol="0" anchor="ctr"/>
           <a:lstStyle/>
           <a:p>
             <a:pPr algn="ctr">
@@ -3598,8 +3826,8 @@
         </p:nvSpPr>
         <p:spPr>
           <a:xfrm>
-            <a:off x="731520" y="1645920"/>
-            <a:ext cx="10728655" cy="4754880"/>
+            <a:off x="1567543" y="1883229"/>
+            <a:ext cx="8599714" cy="2169825"/>
           </a:xfrm>
           <a:prstGeom prst="rect">
             <a:avLst/>
@@ -3611,7 +3839,9 @@
             <a:spAutoFit/>
           </a:bodyPr>
           <a:lstStyle/>
-          <a:p/>
+          <a:p>
+            <a:endParaRPr dirty="0"/>
+          </a:p>
           <a:p>
             <a:pPr>
               <a:defRPr sz="1300">
@@ -3621,6 +3851,7 @@
               </a:defRPr>
             </a:pPr>
             <a:r>
+              <a:rPr dirty="0"/>
               <a:t>Q1: How do you prevent LLM hallucinations? Decision logic is computed in pure Python before the LLM prompt is assembled. LLM is strictly constrained to NLG surface realization.</a:t>
             </a:r>
           </a:p>
@@ -3633,6 +3864,7 @@
               </a:defRPr>
             </a:pPr>
             <a:r>
+              <a:rPr dirty="0"/>
               <a:t>Q2: How does the system handle complex multi-intent messages? Parser extracts all intent components; rules engine evaluates each independently (e.g. approving hotel while escalating fare difference).</a:t>
             </a:r>
           </a:p>
@@ -3645,7 +3877,16 @@
               </a:defRPr>
             </a:pPr>
             <a:r>
-              <a:t>Q3: What happens during API outage or rate limits? Automatic failover to SmartDeterministicClient guarantees 100% uptime with zero downtime.</a:t>
+              <a:rPr dirty="0"/>
+              <a:t>Q3: What happens during API outage or rate limits? Automatic failover to </a:t>
+            </a:r>
+            <a:r>
+              <a:rPr dirty="0" err="1"/>
+              <a:t>SmartDeterministicClient</a:t>
+            </a:r>
+            <a:r>
+              <a:rPr dirty="0"/>
+              <a:t> guarantees 100% uptime with zero downtime.</a:t>
             </a:r>
           </a:p>
           <a:p>
@@ -3657,6 +3898,7 @@
               </a:defRPr>
             </a:pPr>
             <a:r>
+              <a:rPr dirty="0"/>
               <a:t>Q4: How does the agent handle legal threats? Instant keyword and sentiment escalation bypasses normal flow, alerting human specialists with immutable audit logs.</a:t>
             </a:r>
           </a:p>
@@ -3669,6 +3911,7 @@
               </a:defRPr>
             </a:pPr>
             <a:r>
+              <a:rPr dirty="0"/>
               <a:t>Final Summary: A production-grade, grounded, multi-lingual disruption care system built strictly within assignment guidelines.</a:t>
             </a:r>
           </a:p>
@@ -3683,7 +3926,7 @@
 </file>
 
 <file path=ppt/slides/slide2.xml><?xml version="1.0" encoding="utf-8"?>
-<p:sld xmlns:a="http://schemas.openxmlformats.org/drawingml/2006/main" xmlns:p="http://schemas.openxmlformats.org/presentationml/2006/main" xmlns:r="http://schemas.openxmlformats.org/officeDocument/2006/relationships">
+<p:sld xmlns:a="http://schemas.openxmlformats.org/drawingml/2006/main" xmlns:r="http://schemas.openxmlformats.org/officeDocument/2006/relationships" xmlns:p="http://schemas.openxmlformats.org/presentationml/2006/main">
   <p:cSld>
     <p:spTree>
       <p:nvGrpSpPr>
@@ -3691,7 +3934,14 @@
         <p:cNvGrpSpPr/>
         <p:nvPr/>
       </p:nvGrpSpPr>
-      <p:grpSpPr/>
+      <p:grpSpPr>
+        <a:xfrm>
+          <a:off x="0" y="0"/>
+          <a:ext cx="0" cy="0"/>
+          <a:chOff x="0" y="0"/>
+          <a:chExt cx="0" cy="0"/>
+        </a:xfrm>
+      </p:grpSpPr>
       <p:sp>
         <p:nvSpPr>
           <p:cNvPr id="2" name="Rectangle 1"/>
@@ -3700,7 +3950,7 @@
         </p:nvSpPr>
         <p:spPr>
           <a:xfrm>
-            <a:off x="731520" y="457200"/>
+            <a:off x="731522" y="457200"/>
             <a:ext cx="10728655" cy="1005840"/>
           </a:xfrm>
           <a:prstGeom prst="rect">
@@ -3730,7 +3980,7 @@
           </a:fontRef>
         </p:style>
         <p:txBody>
-          <a:bodyPr rtlCol="0" anchor="ctr" wrap="square" lIns="274320" tIns="137160"/>
+          <a:bodyPr wrap="square" lIns="274320" tIns="137160" rtlCol="0" anchor="ctr"/>
           <a:lstStyle/>
           <a:p>
             <a:pPr algn="ctr">
@@ -3766,8 +4016,8 @@
         </p:nvSpPr>
         <p:spPr>
           <a:xfrm>
-            <a:off x="731520" y="1645920"/>
-            <a:ext cx="10728655" cy="4754880"/>
+            <a:off x="1328057" y="2046514"/>
+            <a:ext cx="10132120" cy="2308324"/>
           </a:xfrm>
           <a:prstGeom prst="rect">
             <a:avLst/>
@@ -3779,7 +4029,9 @@
             <a:spAutoFit/>
           </a:bodyPr>
           <a:lstStyle/>
-          <a:p/>
+          <a:p>
+            <a:endParaRPr dirty="0"/>
+          </a:p>
           <a:p>
             <a:pPr>
               <a:defRPr sz="1400">
@@ -3789,6 +4041,7 @@
               </a:defRPr>
             </a:pPr>
             <a:r>
+              <a:rPr dirty="0"/>
               <a:t>The Challenge: Airline disruptions (cancellations and multi-hour delays) cause immense customer frustration, leading to angry passengers demanding arbitrary upgrades, refunds, or threatening legal action.</a:t>
             </a:r>
           </a:p>
@@ -3801,6 +4054,7 @@
               </a:defRPr>
             </a:pPr>
             <a:r>
+              <a:rPr dirty="0"/>
               <a:t>The Business Risk: Pure LLM bots suffer from hallucination, authorizing unauthorized compensation or exceeding financial authority thresholds (e.g. fare difference waivers).</a:t>
             </a:r>
           </a:p>
@@ -3813,6 +4067,7 @@
               </a:defRPr>
             </a:pPr>
             <a:r>
+              <a:rPr dirty="0"/>
               <a:t>The Objective: Build an autonomous customer-facing resolution agent that:</a:t>
             </a:r>
           </a:p>
@@ -3825,6 +4080,7 @@
               </a:defRPr>
             </a:pPr>
             <a:r>
+              <a:rPr dirty="0"/>
               <a:t>  - Understands Intent &amp; Sentiment: Detects customer emotional state and exact request.</a:t>
             </a:r>
           </a:p>
@@ -3837,6 +4093,7 @@
               </a:defRPr>
             </a:pPr>
             <a:r>
+              <a:rPr dirty="0"/>
               <a:t>  - Strictly Enforces Grounded Policy: Determines entitlements deterministically from data pack rules.</a:t>
             </a:r>
           </a:p>
@@ -3849,7 +4106,16 @@
               </a:defRPr>
             </a:pPr>
             <a:r>
-              <a:t>  - Protects Airline Authority: Escalates cases exceeding front-line limits (e.g., fare diff &gt; Rs 1,500, legal threats) to human supervisors.</a:t>
+              <a:rPr dirty="0"/>
+              <a:t>  - Protects Airline Authority: Escalates cases exceeding front-line limits (e.g., fare diff &gt; </a:t>
+            </a:r>
+            <a:r>
+              <a:rPr dirty="0" err="1"/>
+              <a:t>Rs</a:t>
+            </a:r>
+            <a:r>
+              <a:rPr dirty="0"/>
+              <a:t> 1,500, legal threats) to human supervisors.</a:t>
             </a:r>
           </a:p>
           <a:p>
@@ -3861,6 +4127,7 @@
               </a:defRPr>
             </a:pPr>
             <a:r>
+              <a:rPr dirty="0"/>
               <a:t>  - Maintains Full Audit Trail: Preserves append-only immutable records of every turn and decision.</a:t>
             </a:r>
           </a:p>
@@ -3875,7 +4142,7 @@
 </file>
 
 <file path=ppt/slides/slide3.xml><?xml version="1.0" encoding="utf-8"?>
-<p:sld xmlns:a="http://schemas.openxmlformats.org/drawingml/2006/main" xmlns:p="http://schemas.openxmlformats.org/presentationml/2006/main" xmlns:r="http://schemas.openxmlformats.org/officeDocument/2006/relationships">
+<p:sld xmlns:a="http://schemas.openxmlformats.org/drawingml/2006/main" xmlns:r="http://schemas.openxmlformats.org/officeDocument/2006/relationships" xmlns:p="http://schemas.openxmlformats.org/presentationml/2006/main">
   <p:cSld>
     <p:spTree>
       <p:nvGrpSpPr>
@@ -3883,7 +4150,14 @@
         <p:cNvGrpSpPr/>
         <p:nvPr/>
       </p:nvGrpSpPr>
-      <p:grpSpPr/>
+      <p:grpSpPr>
+        <a:xfrm>
+          <a:off x="0" y="0"/>
+          <a:ext cx="0" cy="0"/>
+          <a:chOff x="0" y="0"/>
+          <a:chExt cx="0" cy="0"/>
+        </a:xfrm>
+      </p:grpSpPr>
       <p:sp>
         <p:nvSpPr>
           <p:cNvPr id="2" name="Rectangle 1"/>
@@ -3892,7 +4166,7 @@
         </p:nvSpPr>
         <p:spPr>
           <a:xfrm>
-            <a:off x="731520" y="457200"/>
+            <a:off x="731522" y="457200"/>
             <a:ext cx="10728655" cy="1005840"/>
           </a:xfrm>
           <a:prstGeom prst="rect">
@@ -3922,7 +4196,7 @@
           </a:fontRef>
         </p:style>
         <p:txBody>
-          <a:bodyPr rtlCol="0" anchor="ctr" wrap="square" lIns="274320" tIns="137160"/>
+          <a:bodyPr wrap="square" lIns="274320" tIns="137160" rtlCol="0" anchor="ctr"/>
           <a:lstStyle/>
           <a:p>
             <a:pPr algn="ctr">
@@ -3958,8 +4232,8 @@
         </p:nvSpPr>
         <p:spPr>
           <a:xfrm>
-            <a:off x="731520" y="1645920"/>
-            <a:ext cx="10728655" cy="4754880"/>
+            <a:off x="1262743" y="1992086"/>
+            <a:ext cx="9557657" cy="2769989"/>
           </a:xfrm>
           <a:prstGeom prst="rect">
             <a:avLst/>
@@ -3971,7 +4245,9 @@
             <a:spAutoFit/>
           </a:bodyPr>
           <a:lstStyle/>
-          <a:p/>
+          <a:p>
+            <a:endParaRPr dirty="0"/>
+          </a:p>
           <a:p>
             <a:pPr>
               <a:defRPr sz="1300">
@@ -3981,7 +4257,16 @@
               </a:defRPr>
             </a:pPr>
             <a:r>
-              <a:t>1. Input &amp; Ingestion Layer: Captures multi-turn passenger queries through Streamlit UI with 1-tap passenger switcher and multi-language support (English / Hindi).</a:t>
+              <a:rPr dirty="0"/>
+              <a:t>1. Input &amp; Ingestion Layer: Captures multi-turn passenger queries through </a:t>
+            </a:r>
+            <a:r>
+              <a:rPr dirty="0" err="1"/>
+              <a:t>Streamlit</a:t>
+            </a:r>
+            <a:r>
+              <a:rPr dirty="0"/>
+              <a:t> UI with 1-tap passenger switcher and multi-language support (English / Hindi).</a:t>
             </a:r>
           </a:p>
           <a:p>
@@ -3993,6 +4278,7 @@
               </a:defRPr>
             </a:pPr>
             <a:r>
+              <a:rPr dirty="0"/>
               <a:t>2. Intent &amp; Sentiment Parser: Extracts primary intent (refund, rebook, hotel, voucher, legal threat) and emotional sentiment (furious, frustrated, polite).</a:t>
             </a:r>
           </a:p>
@@ -4005,7 +4291,32 @@
               </a:defRPr>
             </a:pPr>
             <a:r>
-              <a:t>3. Grounded Data Repository: Provides read-only access to customer profiles (Priya, Arvind, Meher), flight statuses, and policy data packs with zero external assumptions.</a:t>
+              <a:rPr dirty="0"/>
+              <a:t>3. Grounded Data Repository: Provides read-only access to customer profiles (</a:t>
+            </a:r>
+            <a:r>
+              <a:rPr dirty="0" err="1"/>
+              <a:t>Priya</a:t>
+            </a:r>
+            <a:r>
+              <a:rPr dirty="0"/>
+              <a:t>, </a:t>
+            </a:r>
+            <a:r>
+              <a:rPr dirty="0" err="1"/>
+              <a:t>Arvind</a:t>
+            </a:r>
+            <a:r>
+              <a:rPr dirty="0"/>
+              <a:t>, </a:t>
+            </a:r>
+            <a:r>
+              <a:rPr dirty="0" err="1"/>
+              <a:t>Meher</a:t>
+            </a:r>
+            <a:r>
+              <a:rPr dirty="0"/>
+              <a:t>), flight statuses, and policy data packs with zero external assumptions.</a:t>
             </a:r>
           </a:p>
           <a:p>
@@ -4017,7 +4328,16 @@
               </a:defRPr>
             </a:pPr>
             <a:r>
-              <a:t>4. Deterministic Rules Engine: Pure Python logic that enforces cancellation rights, delay tiers (&lt;3h, 3-5h, &gt;5h), hotel eligibility, and Rs 1,500 fare waiver limits.</a:t>
+              <a:rPr dirty="0"/>
+              <a:t>4. Deterministic Rules Engine: Pure Python logic that enforces cancellation rights, delay tiers (&lt;3h, 3-5h, &gt;5h), hotel eligibility, and </a:t>
+            </a:r>
+            <a:r>
+              <a:rPr dirty="0" err="1"/>
+              <a:t>Rs</a:t>
+            </a:r>
+            <a:r>
+              <a:rPr dirty="0"/>
+              <a:t> 1,500 fare waiver limits.</a:t>
             </a:r>
           </a:p>
           <a:p>
@@ -4029,6 +4349,7 @@
               </a:defRPr>
             </a:pPr>
             <a:r>
+              <a:rPr dirty="0"/>
               <a:t>5. Controlled NLG &amp; LLM Client: Natural language generation using Google Gemini with offline deterministic fallback for bulletproof offline evaluation.</a:t>
             </a:r>
           </a:p>
@@ -4041,7 +4362,16 @@
               </a:defRPr>
             </a:pPr>
             <a:r>
-              <a:t>6. Audit &amp; Observability Logger: Append-only JSONL event store capturing every turn, policy decisions, supervisor escalations, and compensation logs.</a:t>
+              <a:rPr dirty="0"/>
+              <a:t>6. Audit &amp; </a:t>
+            </a:r>
+            <a:r>
+              <a:rPr dirty="0" err="1"/>
+              <a:t>Observability</a:t>
+            </a:r>
+            <a:r>
+              <a:rPr dirty="0"/>
+              <a:t> Logger: Append-only JSONL event store capturing every turn, policy decisions, supervisor escalations, and compensation logs.</a:t>
             </a:r>
           </a:p>
         </p:txBody>
@@ -4055,7 +4385,7 @@
 </file>
 
 <file path=ppt/slides/slide4.xml><?xml version="1.0" encoding="utf-8"?>
-<p:sld xmlns:a="http://schemas.openxmlformats.org/drawingml/2006/main" xmlns:p="http://schemas.openxmlformats.org/presentationml/2006/main" xmlns:r="http://schemas.openxmlformats.org/officeDocument/2006/relationships">
+<p:sld xmlns:a="http://schemas.openxmlformats.org/drawingml/2006/main" xmlns:r="http://schemas.openxmlformats.org/officeDocument/2006/relationships" xmlns:p="http://schemas.openxmlformats.org/presentationml/2006/main">
   <p:cSld>
     <p:spTree>
       <p:nvGrpSpPr>
@@ -4063,7 +4393,14 @@
         <p:cNvGrpSpPr/>
         <p:nvPr/>
       </p:nvGrpSpPr>
-      <p:grpSpPr/>
+      <p:grpSpPr>
+        <a:xfrm>
+          <a:off x="0" y="0"/>
+          <a:ext cx="0" cy="0"/>
+          <a:chOff x="0" y="0"/>
+          <a:chExt cx="0" cy="0"/>
+        </a:xfrm>
+      </p:grpSpPr>
       <p:sp>
         <p:nvSpPr>
           <p:cNvPr id="2" name="Rectangle 1"/>
@@ -4072,7 +4409,7 @@
         </p:nvSpPr>
         <p:spPr>
           <a:xfrm>
-            <a:off x="731520" y="457200"/>
+            <a:off x="731522" y="457200"/>
             <a:ext cx="10728655" cy="1005840"/>
           </a:xfrm>
           <a:prstGeom prst="rect">
@@ -4102,7 +4439,7 @@
           </a:fontRef>
         </p:style>
         <p:txBody>
-          <a:bodyPr rtlCol="0" anchor="ctr" wrap="square" lIns="274320" tIns="137160"/>
+          <a:bodyPr wrap="square" lIns="274320" tIns="137160" rtlCol="0" anchor="ctr"/>
           <a:lstStyle/>
           <a:p>
             <a:pPr algn="ctr">
@@ -4138,8 +4475,8 @@
         </p:nvSpPr>
         <p:spPr>
           <a:xfrm>
-            <a:off x="731520" y="1645920"/>
-            <a:ext cx="10728655" cy="4754880"/>
+            <a:off x="1393371" y="2286000"/>
+            <a:ext cx="9296400" cy="2446824"/>
           </a:xfrm>
           <a:prstGeom prst="rect">
             <a:avLst/>
@@ -4151,7 +4488,9 @@
             <a:spAutoFit/>
           </a:bodyPr>
           <a:lstStyle/>
-          <a:p/>
+          <a:p>
+            <a:endParaRPr dirty="0"/>
+          </a:p>
           <a:p>
             <a:pPr>
               <a:defRPr sz="1350">
@@ -4161,6 +4500,7 @@
               </a:defRPr>
             </a:pPr>
             <a:r>
+              <a:rPr dirty="0"/>
               <a:t>Cancellation Rebooking Rule: Airline-caused cancellation entitles customer to choice of Free Rebooking within 24h OR Full Refund (7 business days to original payment method).</a:t>
             </a:r>
           </a:p>
@@ -4173,7 +4513,16 @@
               </a:defRPr>
             </a:pPr>
             <a:r>
-              <a:t>Delay Care Tiers: &lt; 3h: Rs 500 Meal Voucher | 3-5h: Meal Voucher + Lounge Access | &gt; 5h: Meal + Lounge + Hotel (delayed-hours duration only, NOT full night).</a:t>
+              <a:rPr dirty="0"/>
+              <a:t>Delay Care Tiers: &lt; 3h: </a:t>
+            </a:r>
+            <a:r>
+              <a:rPr dirty="0" err="1"/>
+              <a:t>Rs</a:t>
+            </a:r>
+            <a:r>
+              <a:rPr dirty="0"/>
+              <a:t> 500 Meal Voucher | 3-5h: Meal Voucher + Lounge Access | &gt; 5h: Meal + Lounge + Hotel (delayed-hours duration only, NOT full night).</a:t>
             </a:r>
           </a:p>
           <a:p>
@@ -4185,7 +4534,24 @@
               </a:defRPr>
             </a:pPr>
             <a:r>
-              <a:t>Fare Difference Waiver Cap: Front-line agent can waive up to Rs 1,500. Any fare difference &gt; Rs 1,500 requires mandatory Duty Supervisor escalation.</a:t>
+              <a:rPr dirty="0"/>
+              <a:t>Fare Difference Waiver Cap: Front-line agent can waive up to </a:t>
+            </a:r>
+            <a:r>
+              <a:rPr dirty="0" err="1"/>
+              <a:t>Rs</a:t>
+            </a:r>
+            <a:r>
+              <a:rPr dirty="0"/>
+              <a:t> 1,500. Any fare difference &gt; </a:t>
+            </a:r>
+            <a:r>
+              <a:rPr dirty="0" err="1"/>
+              <a:t>Rs</a:t>
+            </a:r>
+            <a:r>
+              <a:rPr dirty="0"/>
+              <a:t> 1,500 requires mandatory Duty Supervisor escalation.</a:t>
             </a:r>
           </a:p>
           <a:p>
@@ -4197,6 +4563,7 @@
               </a:defRPr>
             </a:pPr>
             <a:r>
+              <a:rPr dirty="0"/>
               <a:t>Loyalty Tier Privileges: Gold &amp; Platinum members receive first-priority rebooking on replacement flights, but zero unauthorized cash compensation or cabin upgrades.</a:t>
             </a:r>
           </a:p>
@@ -4209,6 +4576,7 @@
               </a:defRPr>
             </a:pPr>
             <a:r>
+              <a:rPr dirty="0"/>
               <a:t>Prohibited Actions (Hard Guardrails): No complimentary business class upgrades; no cash beyond policy; immediate escalation on legal/court/formal complaint threats.</a:t>
             </a:r>
           </a:p>
@@ -4223,7 +4591,7 @@
 </file>
 
 <file path=ppt/slides/slide5.xml><?xml version="1.0" encoding="utf-8"?>
-<p:sld xmlns:a="http://schemas.openxmlformats.org/drawingml/2006/main" xmlns:p="http://schemas.openxmlformats.org/presentationml/2006/main" xmlns:r="http://schemas.openxmlformats.org/officeDocument/2006/relationships">
+<p:sld xmlns:a="http://schemas.openxmlformats.org/drawingml/2006/main" xmlns:r="http://schemas.openxmlformats.org/officeDocument/2006/relationships" xmlns:p="http://schemas.openxmlformats.org/presentationml/2006/main">
   <p:cSld>
     <p:spTree>
       <p:nvGrpSpPr>
@@ -4231,7 +4599,14 @@
         <p:cNvGrpSpPr/>
         <p:nvPr/>
       </p:nvGrpSpPr>
-      <p:grpSpPr/>
+      <p:grpSpPr>
+        <a:xfrm>
+          <a:off x="0" y="0"/>
+          <a:ext cx="0" cy="0"/>
+          <a:chOff x="0" y="0"/>
+          <a:chExt cx="0" cy="0"/>
+        </a:xfrm>
+      </p:grpSpPr>
       <p:sp>
         <p:nvSpPr>
           <p:cNvPr id="2" name="Rectangle 1"/>
@@ -4240,7 +4615,7 @@
         </p:nvSpPr>
         <p:spPr>
           <a:xfrm>
-            <a:off x="731520" y="457200"/>
+            <a:off x="731522" y="457200"/>
             <a:ext cx="10728655" cy="1005840"/>
           </a:xfrm>
           <a:prstGeom prst="rect">
@@ -4270,7 +4645,7 @@
           </a:fontRef>
         </p:style>
         <p:txBody>
-          <a:bodyPr rtlCol="0" anchor="ctr" wrap="square" lIns="274320" tIns="137160"/>
+          <a:bodyPr wrap="square" lIns="274320" tIns="137160" rtlCol="0" anchor="ctr"/>
           <a:lstStyle/>
           <a:p>
             <a:pPr algn="ctr">
@@ -4306,8 +4681,8 @@
         </p:nvSpPr>
         <p:spPr>
           <a:xfrm>
-            <a:off x="731520" y="1645920"/>
-            <a:ext cx="10728655" cy="4754880"/>
+            <a:off x="1436914" y="1970314"/>
+            <a:ext cx="9339943" cy="2031325"/>
           </a:xfrm>
           <a:prstGeom prst="rect">
             <a:avLst/>
@@ -4319,7 +4694,9 @@
             <a:spAutoFit/>
           </a:bodyPr>
           <a:lstStyle/>
-          <a:p/>
+          <a:p>
+            <a:endParaRPr dirty="0"/>
+          </a:p>
           <a:p>
             <a:pPr>
               <a:defRPr sz="1350">
@@ -4329,6 +4706,7 @@
               </a:defRPr>
             </a:pPr>
             <a:r>
+              <a:rPr dirty="0"/>
               <a:t>Flight Status: Flight SK-204 (Delhi -&gt; Goa) is CANCELLED for operational reasons.</a:t>
             </a:r>
           </a:p>
@@ -4341,6 +4719,7 @@
               </a:defRPr>
             </a:pPr>
             <a:r>
+              <a:rPr dirty="0"/>
               <a:t>Customer State &amp; Demands: Customer is "furious", demands a full cash refund PLUS a free business class upgrade on her return flight "for the trouble".</a:t>
             </a:r>
           </a:p>
@@ -4353,6 +4732,7 @@
               </a:defRPr>
             </a:pPr>
             <a:r>
+              <a:rPr dirty="0"/>
               <a:t>Agent Resolution Strategy: </a:t>
             </a:r>
           </a:p>
@@ -4365,6 +4745,7 @@
               </a:defRPr>
             </a:pPr>
             <a:r>
+              <a:rPr dirty="0"/>
               <a:t>  - Empathetic De-escalation: Acknowledges Gold loyalty status and expresses sincere apology for the disruption.</a:t>
             </a:r>
           </a:p>
@@ -4377,6 +4758,7 @@
               </a:defRPr>
             </a:pPr>
             <a:r>
+              <a:rPr dirty="0"/>
               <a:t>  - Grounded Options Offered: Presents 100% Full Refund (7 business days) OR Free Priority Rebooking on the next flight within 24h.</a:t>
             </a:r>
           </a:p>
@@ -4389,6 +4771,7 @@
               </a:defRPr>
             </a:pPr>
             <a:r>
+              <a:rPr dirty="0"/>
               <a:t>  - Policy Boundary Upheld: Politely declines complimentary business class upgrade, citing strict airline disruption policy.</a:t>
             </a:r>
           </a:p>
@@ -4401,6 +4784,7 @@
               </a:defRPr>
             </a:pPr>
             <a:r>
+              <a:rPr dirty="0"/>
               <a:t>  - Zero Policy Violation: Does not concede unauthorized upgrade despite high customer agitation.</a:t>
             </a:r>
           </a:p>
@@ -4415,7 +4799,7 @@
 </file>
 
 <file path=ppt/slides/slide6.xml><?xml version="1.0" encoding="utf-8"?>
-<p:sld xmlns:a="http://schemas.openxmlformats.org/drawingml/2006/main" xmlns:p="http://schemas.openxmlformats.org/presentationml/2006/main" xmlns:r="http://schemas.openxmlformats.org/officeDocument/2006/relationships">
+<p:sld xmlns:a="http://schemas.openxmlformats.org/drawingml/2006/main" xmlns:r="http://schemas.openxmlformats.org/officeDocument/2006/relationships" xmlns:p="http://schemas.openxmlformats.org/presentationml/2006/main">
   <p:cSld>
     <p:spTree>
       <p:nvGrpSpPr>
@@ -4423,7 +4807,14 @@
         <p:cNvGrpSpPr/>
         <p:nvPr/>
       </p:nvGrpSpPr>
-      <p:grpSpPr/>
+      <p:grpSpPr>
+        <a:xfrm>
+          <a:off x="0" y="0"/>
+          <a:ext cx="0" cy="0"/>
+          <a:chOff x="0" y="0"/>
+          <a:chExt cx="0" cy="0"/>
+        </a:xfrm>
+      </p:grpSpPr>
       <p:sp>
         <p:nvSpPr>
           <p:cNvPr id="2" name="Rectangle 1"/>
@@ -4432,7 +4823,7 @@
         </p:nvSpPr>
         <p:spPr>
           <a:xfrm>
-            <a:off x="731520" y="457200"/>
+            <a:off x="731522" y="457200"/>
             <a:ext cx="10728655" cy="1005840"/>
           </a:xfrm>
           <a:prstGeom prst="rect">
@@ -4462,7 +4853,7 @@
           </a:fontRef>
         </p:style>
         <p:txBody>
-          <a:bodyPr rtlCol="0" anchor="ctr" wrap="square" lIns="274320" tIns="137160"/>
+          <a:bodyPr wrap="square" lIns="274320" tIns="137160" rtlCol="0" anchor="ctr"/>
           <a:lstStyle/>
           <a:p>
             <a:pPr algn="ctr">
@@ -4498,8 +4889,8 @@
         </p:nvSpPr>
         <p:spPr>
           <a:xfrm>
-            <a:off x="731520" y="1645920"/>
-            <a:ext cx="10728655" cy="4754880"/>
+            <a:off x="1545771" y="2231571"/>
+            <a:ext cx="9914406" cy="1823576"/>
           </a:xfrm>
           <a:prstGeom prst="rect">
             <a:avLst/>
@@ -4511,7 +4902,9 @@
             <a:spAutoFit/>
           </a:bodyPr>
           <a:lstStyle/>
-          <a:p/>
+          <a:p>
+            <a:endParaRPr dirty="0"/>
+          </a:p>
           <a:p>
             <a:pPr>
               <a:defRPr sz="1350">
@@ -4521,6 +4914,7 @@
               </a:defRPr>
             </a:pPr>
             <a:r>
+              <a:rPr dirty="0"/>
               <a:t>Flight Status: Flight SK-118 (Mumbai -&gt; Bengaluru) is DELAYED by 4 Hours (rescheduled to 11:10).</a:t>
             </a:r>
           </a:p>
@@ -4533,6 +4927,7 @@
               </a:defRPr>
             </a:pPr>
             <a:r>
+              <a:rPr dirty="0"/>
               <a:t>Customer State &amp; Demands: Customer is frustrated about missing a connecting business meeting and demands hotel accommodation.</a:t>
             </a:r>
           </a:p>
@@ -4545,6 +4940,7 @@
               </a:defRPr>
             </a:pPr>
             <a:r>
+              <a:rPr dirty="0"/>
               <a:t>Agent Resolution Strategy: </a:t>
             </a:r>
           </a:p>
@@ -4557,6 +4953,7 @@
               </a:defRPr>
             </a:pPr>
             <a:r>
+              <a:rPr dirty="0"/>
               <a:t>  - Immediate Care Entitlements: Issues Meal Voucher and activates Executive Lounge Access per 3-5 hour delay tier.</a:t>
             </a:r>
           </a:p>
@@ -4569,6 +4966,7 @@
               </a:defRPr>
             </a:pPr>
             <a:r>
+              <a:rPr dirty="0"/>
               <a:t>  - Hotel Policy Enforcement: Politely explains hotel accommodation is strictly reserved for delays &gt; 5 hours; denies hotel stay.</a:t>
             </a:r>
           </a:p>
@@ -4581,6 +4979,7 @@
               </a:defRPr>
             </a:pPr>
             <a:r>
+              <a:rPr dirty="0"/>
               <a:t>  - Hospitality Alternative: Invites customer to work comfortably from the departure lounge with full amenities.</a:t>
             </a:r>
           </a:p>
@@ -4593,6 +4992,7 @@
               </a:defRPr>
             </a:pPr>
             <a:r>
+              <a:rPr dirty="0"/>
               <a:t>  - Precision Compliance: Exact match with civil aviation delay compensation guidelines.</a:t>
             </a:r>
           </a:p>
@@ -4607,7 +5007,7 @@
 </file>
 
 <file path=ppt/slides/slide7.xml><?xml version="1.0" encoding="utf-8"?>
-<p:sld xmlns:a="http://schemas.openxmlformats.org/drawingml/2006/main" xmlns:p="http://schemas.openxmlformats.org/presentationml/2006/main" xmlns:r="http://schemas.openxmlformats.org/officeDocument/2006/relationships">
+<p:sld xmlns:a="http://schemas.openxmlformats.org/drawingml/2006/main" xmlns:r="http://schemas.openxmlformats.org/officeDocument/2006/relationships" xmlns:p="http://schemas.openxmlformats.org/presentationml/2006/main">
   <p:cSld>
     <p:spTree>
       <p:nvGrpSpPr>
@@ -4615,7 +5015,14 @@
         <p:cNvGrpSpPr/>
         <p:nvPr/>
       </p:nvGrpSpPr>
-      <p:grpSpPr/>
+      <p:grpSpPr>
+        <a:xfrm>
+          <a:off x="0" y="0"/>
+          <a:ext cx="0" cy="0"/>
+          <a:chOff x="0" y="0"/>
+          <a:chExt cx="0" cy="0"/>
+        </a:xfrm>
+      </p:grpSpPr>
       <p:sp>
         <p:nvSpPr>
           <p:cNvPr id="2" name="Rectangle 1"/>
@@ -4624,7 +5031,7 @@
         </p:nvSpPr>
         <p:spPr>
           <a:xfrm>
-            <a:off x="731520" y="457200"/>
+            <a:off x="731522" y="457200"/>
             <a:ext cx="10728655" cy="1005840"/>
           </a:xfrm>
           <a:prstGeom prst="rect">
@@ -4654,7 +5061,7 @@
           </a:fontRef>
         </p:style>
         <p:txBody>
-          <a:bodyPr rtlCol="0" anchor="ctr" wrap="square" lIns="274320" tIns="137160"/>
+          <a:bodyPr wrap="square" lIns="274320" tIns="137160" rtlCol="0" anchor="ctr"/>
           <a:lstStyle/>
           <a:p>
             <a:pPr algn="ctr">
@@ -4690,8 +5097,8 @@
         </p:nvSpPr>
         <p:spPr>
           <a:xfrm>
-            <a:off x="731520" y="1645920"/>
-            <a:ext cx="10728655" cy="4754880"/>
+            <a:off x="1513114" y="2166257"/>
+            <a:ext cx="9252857" cy="2239074"/>
           </a:xfrm>
           <a:prstGeom prst="rect">
             <a:avLst/>
@@ -4703,7 +5110,9 @@
             <a:spAutoFit/>
           </a:bodyPr>
           <a:lstStyle/>
-          <a:p/>
+          <a:p>
+            <a:endParaRPr dirty="0"/>
+          </a:p>
           <a:p>
             <a:pPr>
               <a:defRPr sz="1350">
@@ -4713,6 +5122,7 @@
               </a:defRPr>
             </a:pPr>
             <a:r>
+              <a:rPr dirty="0"/>
               <a:t>Flight Status: Flight SK-305 (Delhi -&gt; Hyderabad) is DELAYED by 6 Hours (rescheduled to 20:00).</a:t>
             </a:r>
           </a:p>
@@ -4725,7 +5135,16 @@
               </a:defRPr>
             </a:pPr>
             <a:r>
-              <a:t>Customer Demands: Requests a full night hotel stay (not just delay hours) AND rebooking to an earlier alternative flight with a Rs 2,000 fare difference.</a:t>
+              <a:rPr dirty="0"/>
+              <a:t>Customer Demands: Requests a full night hotel stay (not just delay hours) AND rebooking to an earlier alternative flight with a </a:t>
+            </a:r>
+            <a:r>
+              <a:rPr dirty="0" err="1"/>
+              <a:t>Rs</a:t>
+            </a:r>
+            <a:r>
+              <a:rPr dirty="0"/>
+              <a:t> 2,000 fare difference.</a:t>
             </a:r>
           </a:p>
           <a:p>
@@ -4737,6 +5156,7 @@
               </a:defRPr>
             </a:pPr>
             <a:r>
+              <a:rPr dirty="0"/>
               <a:t>Agent Resolution Strategy: </a:t>
             </a:r>
           </a:p>
@@ -4749,6 +5169,7 @@
               </a:defRPr>
             </a:pPr>
             <a:r>
+              <a:rPr dirty="0"/>
               <a:t>  - 6-Hour Delay Care: Issues Meal Voucher + Executive Lounge Access + Transit Hotel accommodation covering the delay duration only.</a:t>
             </a:r>
           </a:p>
@@ -4761,7 +5182,24 @@
               </a:defRPr>
             </a:pPr>
             <a:r>
-              <a:t>  - Authority Boundary Enforcement: Detects that the Rs 2,000 fare difference exceeds front-line waiver threshold of Rs 1,500.</a:t>
+              <a:rPr dirty="0"/>
+              <a:t>  - Authority Boundary Enforcement: Detects that the </a:t>
+            </a:r>
+            <a:r>
+              <a:rPr dirty="0" err="1"/>
+              <a:t>Rs</a:t>
+            </a:r>
+            <a:r>
+              <a:rPr dirty="0"/>
+              <a:t> 2,000 fare difference exceeds front-line waiver threshold of </a:t>
+            </a:r>
+            <a:r>
+              <a:rPr dirty="0" err="1"/>
+              <a:t>Rs</a:t>
+            </a:r>
+            <a:r>
+              <a:rPr dirty="0"/>
+              <a:t> 1,500.</a:t>
             </a:r>
           </a:p>
           <a:p>
@@ -4773,6 +5211,7 @@
               </a:defRPr>
             </a:pPr>
             <a:r>
+              <a:rPr dirty="0"/>
               <a:t>  - Platinum Supervisor Escalation: Immediately escalates fare difference approval to Duty Supervisor with Platinum Priority tag.</a:t>
             </a:r>
           </a:p>
@@ -4785,6 +5224,7 @@
               </a:defRPr>
             </a:pPr>
             <a:r>
+              <a:rPr dirty="0"/>
               <a:t>  - Partial Fulfillment: Grants authorized items directly while escalating out-of-scope items cleanly.</a:t>
             </a:r>
           </a:p>
@@ -4799,7 +5239,7 @@
 </file>
 
 <file path=ppt/slides/slide8.xml><?xml version="1.0" encoding="utf-8"?>
-<p:sld xmlns:a="http://schemas.openxmlformats.org/drawingml/2006/main" xmlns:p="http://schemas.openxmlformats.org/presentationml/2006/main" xmlns:r="http://schemas.openxmlformats.org/officeDocument/2006/relationships">
+<p:sld xmlns:a="http://schemas.openxmlformats.org/drawingml/2006/main" xmlns:r="http://schemas.openxmlformats.org/officeDocument/2006/relationships" xmlns:p="http://schemas.openxmlformats.org/presentationml/2006/main">
   <p:cSld>
     <p:spTree>
       <p:nvGrpSpPr>
@@ -4807,7 +5247,14 @@
         <p:cNvGrpSpPr/>
         <p:nvPr/>
       </p:nvGrpSpPr>
-      <p:grpSpPr/>
+      <p:grpSpPr>
+        <a:xfrm>
+          <a:off x="0" y="0"/>
+          <a:ext cx="0" cy="0"/>
+          <a:chOff x="0" y="0"/>
+          <a:chExt cx="0" cy="0"/>
+        </a:xfrm>
+      </p:grpSpPr>
       <p:sp>
         <p:nvSpPr>
           <p:cNvPr id="2" name="Rectangle 1"/>
@@ -4816,7 +5263,7 @@
         </p:nvSpPr>
         <p:spPr>
           <a:xfrm>
-            <a:off x="731520" y="457200"/>
+            <a:off x="731522" y="457200"/>
             <a:ext cx="10728655" cy="1005840"/>
           </a:xfrm>
           <a:prstGeom prst="rect">
@@ -4846,7 +5293,7 @@
           </a:fontRef>
         </p:style>
         <p:txBody>
-          <a:bodyPr rtlCol="0" anchor="ctr" wrap="square" lIns="274320" tIns="137160"/>
+          <a:bodyPr wrap="square" lIns="274320" tIns="137160" rtlCol="0" anchor="ctr"/>
           <a:lstStyle/>
           <a:p>
             <a:pPr algn="ctr">
@@ -4882,8 +5329,8 @@
         </p:nvSpPr>
         <p:spPr>
           <a:xfrm>
-            <a:off x="731520" y="1645920"/>
-            <a:ext cx="10728655" cy="4754880"/>
+            <a:off x="2231571" y="2307770"/>
+            <a:ext cx="7696200" cy="3070071"/>
           </a:xfrm>
           <a:prstGeom prst="rect">
             <a:avLst/>
@@ -4895,7 +5342,9 @@
             <a:spAutoFit/>
           </a:bodyPr>
           <a:lstStyle/>
-          <a:p/>
+          <a:p>
+            <a:endParaRPr dirty="0"/>
+          </a:p>
           <a:p>
             <a:pPr>
               <a:defRPr sz="1350">
@@ -4905,6 +5354,7 @@
               </a:defRPr>
             </a:pPr>
             <a:r>
+              <a:rPr dirty="0"/>
               <a:t>Core Language Model: Google Gemini 2.5 Flash API (low temperature 0.2 for strict grounding) with deterministic rule synthesis.</a:t>
             </a:r>
           </a:p>
@@ -4917,7 +5367,16 @@
               </a:defRPr>
             </a:pPr>
             <a:r>
-              <a:t>Deterministic Fallback: SmartDeterministicClient with regex intent classifier enabling 100% offline recruiter evaluation.</a:t>
+              <a:rPr dirty="0"/>
+              <a:t>Deterministic Fallback: </a:t>
+            </a:r>
+            <a:r>
+              <a:rPr dirty="0" err="1"/>
+              <a:t>SmartDeterministicClient</a:t>
+            </a:r>
+            <a:r>
+              <a:rPr dirty="0"/>
+              <a:t> with regex intent classifier enabling 100% offline recruiter evaluation.</a:t>
             </a:r>
           </a:p>
           <a:p>
@@ -4929,7 +5388,16 @@
               </a:defRPr>
             </a:pPr>
             <a:r>
-              <a:t>Frontend Framework: Streamlit with Custom CSS Aviation Sky/Starry Night themes and 1-tap passenger switcher.</a:t>
+              <a:rPr dirty="0"/>
+              <a:t>Frontend Framework: </a:t>
+            </a:r>
+            <a:r>
+              <a:rPr dirty="0" err="1"/>
+              <a:t>Streamlit</a:t>
+            </a:r>
+            <a:r>
+              <a:rPr dirty="0"/>
+              <a:t> with Custom CSS Aviation Sky/Starry Night themes and 1-tap passenger switcher.</a:t>
             </a:r>
           </a:p>
           <a:p>
@@ -4941,7 +5409,16 @@
               </a:defRPr>
             </a:pPr>
             <a:r>
-              <a:t>PDF Certificate Engine: ReportLab 5.0 for dynamic issuance of official Disruption Claim Slips &amp; Tax Invoices.</a:t>
+              <a:rPr dirty="0"/>
+              <a:t>PDF Certificate Engine: </a:t>
+            </a:r>
+            <a:r>
+              <a:rPr dirty="0" err="1"/>
+              <a:t>ReportLab</a:t>
+            </a:r>
+            <a:r>
+              <a:rPr dirty="0"/>
+              <a:t> 5.0 for dynamic issuance of official Disruption Claim Slips &amp; Tax Invoices.</a:t>
             </a:r>
           </a:p>
           <a:p>
@@ -4953,7 +5430,16 @@
               </a:defRPr>
             </a:pPr>
             <a:r>
-              <a:t>Multi-Language Engine: Bilingual translation layer (English &lt;-&gt; हिन्दी) adapting UI and conversational responses.</a:t>
+              <a:rPr dirty="0"/>
+              <a:t>Multi-Language Engine: Bilingual translation layer (English &lt;-&gt; </a:t>
+            </a:r>
+            <a:r>
+              <a:rPr dirty="0" err="1"/>
+              <a:t>हिन्दी</a:t>
+            </a:r>
+            <a:r>
+              <a:rPr dirty="0"/>
+              <a:t>) adapting UI and conversational responses.</a:t>
             </a:r>
           </a:p>
           <a:p>
@@ -4965,7 +5451,16 @@
               </a:defRPr>
             </a:pPr>
             <a:r>
-              <a:t>Testing &amp; QA: PyTest suite with 55 unit/integration tests verifying 100% rules engine and data repository coverage.</a:t>
+              <a:rPr dirty="0"/>
+              <a:t>Testing &amp; QA: </a:t>
+            </a:r>
+            <a:r>
+              <a:rPr dirty="0" err="1"/>
+              <a:t>PyTest</a:t>
+            </a:r>
+            <a:r>
+              <a:rPr dirty="0"/>
+              <a:t> suite with 55 unit/integration tests verifying 100% rules engine and data repository coverage.</a:t>
             </a:r>
           </a:p>
           <a:p>
@@ -4977,6 +5472,7 @@
               </a:defRPr>
             </a:pPr>
             <a:r>
+              <a:rPr dirty="0"/>
               <a:t>Audit Infrastructure: Append-only JSONL logger tracking timestamps, customer sentiment drift, and supervisor actions.</a:t>
             </a:r>
           </a:p>
@@ -4991,7 +5487,7 @@
 </file>
 
 <file path=ppt/slides/slide9.xml><?xml version="1.0" encoding="utf-8"?>
-<p:sld xmlns:a="http://schemas.openxmlformats.org/drawingml/2006/main" xmlns:p="http://schemas.openxmlformats.org/presentationml/2006/main" xmlns:r="http://schemas.openxmlformats.org/officeDocument/2006/relationships">
+<p:sld xmlns:a="http://schemas.openxmlformats.org/drawingml/2006/main" xmlns:r="http://schemas.openxmlformats.org/officeDocument/2006/relationships" xmlns:p="http://schemas.openxmlformats.org/presentationml/2006/main">
   <p:cSld>
     <p:spTree>
       <p:nvGrpSpPr>
@@ -4999,7 +5495,14 @@
         <p:cNvGrpSpPr/>
         <p:nvPr/>
       </p:nvGrpSpPr>
-      <p:grpSpPr/>
+      <p:grpSpPr>
+        <a:xfrm>
+          <a:off x="0" y="0"/>
+          <a:ext cx="0" cy="0"/>
+          <a:chOff x="0" y="0"/>
+          <a:chExt cx="0" cy="0"/>
+        </a:xfrm>
+      </p:grpSpPr>
       <p:sp>
         <p:nvSpPr>
           <p:cNvPr id="2" name="Rectangle 1"/>
@@ -5008,7 +5511,7 @@
         </p:nvSpPr>
         <p:spPr>
           <a:xfrm>
-            <a:off x="731520" y="457200"/>
+            <a:off x="731522" y="457200"/>
             <a:ext cx="10728655" cy="1005840"/>
           </a:xfrm>
           <a:prstGeom prst="rect">
@@ -5038,7 +5541,7 @@
           </a:fontRef>
         </p:style>
         <p:txBody>
-          <a:bodyPr rtlCol="0" anchor="ctr" wrap="square" lIns="274320" tIns="137160"/>
+          <a:bodyPr wrap="square" lIns="274320" tIns="137160" rtlCol="0" anchor="ctr"/>
           <a:lstStyle/>
           <a:p>
             <a:pPr algn="ctr">
@@ -5074,8 +5577,8 @@
         </p:nvSpPr>
         <p:spPr>
           <a:xfrm>
-            <a:off x="731520" y="1645920"/>
-            <a:ext cx="10728655" cy="4754880"/>
+            <a:off x="1970314" y="1709058"/>
+            <a:ext cx="7347857" cy="2523768"/>
           </a:xfrm>
           <a:prstGeom prst="rect">
             <a:avLst/>
@@ -5087,7 +5590,9 @@
             <a:spAutoFit/>
           </a:bodyPr>
           <a:lstStyle/>
-          <a:p/>
+          <a:p>
+            <a:endParaRPr dirty="0"/>
+          </a:p>
           <a:p>
             <a:pPr>
               <a:defRPr sz="1400">
@@ -5097,6 +5602,7 @@
               </a:defRPr>
             </a:pPr>
             <a:r>
+              <a:rPr dirty="0"/>
               <a:t>Average Resolution Time: Reduced from 18 minutes (manual human phone queue) to under 15 seconds (98.6% faster).</a:t>
             </a:r>
           </a:p>
@@ -5109,6 +5615,7 @@
               </a:defRPr>
             </a:pPr>
             <a:r>
+              <a:rPr dirty="0"/>
               <a:t>Operational Cost Reduction: Resolves ~75% of disruption interactions without human agent intervention, cutting support costs by 68%.</a:t>
             </a:r>
           </a:p>
@@ -5121,6 +5628,7 @@
               </a:defRPr>
             </a:pPr>
             <a:r>
+              <a:rPr dirty="0"/>
               <a:t>Policy Compliance Rate: 100% zero unauthorized compensation leakage (zero hallucinated business class upgrades or unapproved waivers).</a:t>
             </a:r>
           </a:p>
@@ -5133,6 +5641,7 @@
               </a:defRPr>
             </a:pPr>
             <a:r>
+              <a:rPr dirty="0"/>
               <a:t>Customer NPS Impact: Instant meal/lounge voucher delivery and transparent claim certificates increase retention during crisis events.</a:t>
             </a:r>
           </a:p>
@@ -5145,6 +5654,7 @@
               </a:defRPr>
             </a:pPr>
             <a:r>
+              <a:rPr dirty="0"/>
               <a:t>Supervisor Productivity: Supervisors receive pre-classified, structured escalation dossiers with exact policy context.</a:t>
             </a:r>
           </a:p>
@@ -5159,9 +5669,9 @@
 </file>
 
 <file path=ppt/theme/theme1.xml><?xml version="1.0" encoding="utf-8"?>
-<a:theme xmlns:a="http://schemas.openxmlformats.org/drawingml/2006/main" name="Office Theme">
+<a:theme xmlns:a="http://schemas.openxmlformats.org/drawingml/2006/main" name="Couture">
   <a:themeElements>
-    <a:clrScheme name="Office">
+    <a:clrScheme name="Couture">
       <a:dk1>
         <a:sysClr val="windowText" lastClr="000000"/>
       </a:dk1>
@@ -5169,52 +5679,54 @@
         <a:sysClr val="window" lastClr="FFFFFF"/>
       </a:lt1>
       <a:dk2>
-        <a:srgbClr val="1F497D"/>
+        <a:srgbClr val="37302A"/>
       </a:dk2>
       <a:lt2>
-        <a:srgbClr val="EEECE1"/>
+        <a:srgbClr val="D0CCB9"/>
       </a:lt2>
       <a:accent1>
-        <a:srgbClr val="4F81BD"/>
+        <a:srgbClr val="9E8E5C"/>
       </a:accent1>
       <a:accent2>
-        <a:srgbClr val="C0504D"/>
+        <a:srgbClr val="A09781"/>
       </a:accent2>
       <a:accent3>
-        <a:srgbClr val="9BBB59"/>
+        <a:srgbClr val="85776D"/>
       </a:accent3>
       <a:accent4>
-        <a:srgbClr val="8064A2"/>
+        <a:srgbClr val="AEAFA9"/>
       </a:accent4>
       <a:accent5>
-        <a:srgbClr val="4BACC6"/>
+        <a:srgbClr val="8D878B"/>
       </a:accent5>
       <a:accent6>
-        <a:srgbClr val="F79646"/>
+        <a:srgbClr val="6B6149"/>
       </a:accent6>
       <a:hlink>
-        <a:srgbClr val="0000FF"/>
+        <a:srgbClr val="B6A272"/>
       </a:hlink>
       <a:folHlink>
-        <a:srgbClr val="800080"/>
+        <a:srgbClr val="8A784F"/>
       </a:folHlink>
     </a:clrScheme>
-    <a:fontScheme name="Office">
+    <a:fontScheme name="Black Tie">
       <a:majorFont>
-        <a:latin typeface="Calibri"/>
+        <a:latin typeface="Garamond"/>
         <a:ea typeface=""/>
         <a:cs typeface=""/>
-        <a:font script="Jpan" typeface="ＭＳ Ｐゴシック"/>
-        <a:font script="Hang" typeface="맑은 고딕"/>
-        <a:font script="Hans" typeface="宋体"/>
-        <a:font script="Hant" typeface="新細明體"/>
+        <a:font script="Grek" typeface="Constantia"/>
+        <a:font script="Cyrl" typeface="Constantia"/>
+        <a:font script="Jpan" typeface="ＭＳ Ｐ明朝"/>
+        <a:font script="Hang" typeface="궁서"/>
+        <a:font script="Hans" typeface="仿宋"/>
+        <a:font script="Hant" typeface="標楷體"/>
         <a:font script="Arab" typeface="Times New Roman"/>
         <a:font script="Hebr" typeface="Times New Roman"/>
         <a:font script="Thai" typeface="Angsana New"/>
         <a:font script="Ethi" typeface="Nyala"/>
         <a:font script="Beng" typeface="Vrinda"/>
         <a:font script="Gujr" typeface="Shruti"/>
-        <a:font script="Khmr" typeface="MoolBoran"/>
+        <a:font script="Khmr" typeface="DaunPenh"/>
         <a:font script="Knda" typeface="Tunga"/>
         <a:font script="Guru" typeface="Raavi"/>
         <a:font script="Cans" typeface="Euphemia"/>
@@ -5236,16 +5748,18 @@
         <a:font script="Geor" typeface="Sylfaen"/>
       </a:majorFont>
       <a:minorFont>
-        <a:latin typeface="Calibri"/>
+        <a:latin typeface="Garamond"/>
         <a:ea typeface=""/>
         <a:cs typeface=""/>
-        <a:font script="Jpan" typeface="ＭＳ Ｐゴシック"/>
-        <a:font script="Hang" typeface="맑은 고딕"/>
-        <a:font script="Hans" typeface="宋体"/>
-        <a:font script="Hant" typeface="新細明體"/>
-        <a:font script="Arab" typeface="Arial"/>
-        <a:font script="Hebr" typeface="Arial"/>
-        <a:font script="Thai" typeface="Cordia New"/>
+        <a:font script="Grek" typeface="Constantia"/>
+        <a:font script="Cyrl" typeface="Constantia"/>
+        <a:font script="Jpan" typeface="ＭＳ Ｐ明朝"/>
+        <a:font script="Hang" typeface="궁서"/>
+        <a:font script="Hans" typeface="仿宋"/>
+        <a:font script="Hant" typeface="標楷體"/>
+        <a:font script="Arab" typeface="Times New Roman"/>
+        <a:font script="Hebr" typeface="Times New Roman"/>
+        <a:font script="Thai" typeface="Angsana New"/>
         <a:font script="Ethi" typeface="Nyala"/>
         <a:font script="Beng" typeface="Vrinda"/>
         <a:font script="Gujr" typeface="Shruti"/>
@@ -5266,106 +5780,64 @@
         <a:font script="Laoo" typeface="DokChampa"/>
         <a:font script="Sinh" typeface="Iskoola Pota"/>
         <a:font script="Mong" typeface="Mongolian Baiti"/>
-        <a:font script="Viet" typeface="Arial"/>
+        <a:font script="Viet" typeface="Times New Roman"/>
         <a:font script="Uigh" typeface="Microsoft Uighur"/>
         <a:font script="Geor" typeface="Sylfaen"/>
       </a:minorFont>
     </a:fontScheme>
-    <a:fmtScheme name="Office">
+    <a:fmtScheme name="Couture">
       <a:fillStyleLst>
         <a:solidFill>
           <a:schemeClr val="phClr"/>
         </a:solidFill>
-        <a:gradFill rotWithShape="1">
-          <a:gsLst>
-            <a:gs pos="0">
-              <a:schemeClr val="phClr">
-                <a:tint val="50000"/>
-                <a:satMod val="300000"/>
-              </a:schemeClr>
-            </a:gs>
-            <a:gs pos="35000">
-              <a:schemeClr val="phClr">
-                <a:tint val="37000"/>
-                <a:satMod val="300000"/>
-              </a:schemeClr>
-            </a:gs>
-            <a:gs pos="100000">
-              <a:schemeClr val="phClr">
-                <a:tint val="15000"/>
-                <a:satMod val="350000"/>
-              </a:schemeClr>
-            </a:gs>
-          </a:gsLst>
-          <a:lin ang="16200000" scaled="1"/>
-        </a:gradFill>
-        <a:gradFill rotWithShape="1">
-          <a:gsLst>
-            <a:gs pos="0">
-              <a:schemeClr val="phClr">
-                <a:tint val="100000"/>
-                <a:shade val="100000"/>
-                <a:satMod val="130000"/>
-              </a:schemeClr>
-            </a:gs>
-            <a:gs pos="100000">
-              <a:schemeClr val="phClr">
-                <a:tint val="50000"/>
-                <a:shade val="100000"/>
-                <a:satMod val="350000"/>
-              </a:schemeClr>
-            </a:gs>
-          </a:gsLst>
-          <a:lin ang="16200000" scaled="0"/>
-        </a:gradFill>
+        <a:solidFill>
+          <a:schemeClr val="phClr">
+            <a:tint val="65000"/>
+          </a:schemeClr>
+        </a:solidFill>
+        <a:solidFill>
+          <a:schemeClr val="phClr">
+            <a:shade val="80000"/>
+            <a:satMod val="180000"/>
+          </a:schemeClr>
+        </a:solidFill>
       </a:fillStyleLst>
       <a:lnStyleLst>
         <a:ln w="9525" cap="flat" cmpd="sng" algn="ctr">
-          <a:solidFill>
-            <a:schemeClr val="phClr">
-              <a:shade val="95000"/>
-              <a:satMod val="105000"/>
-            </a:schemeClr>
-          </a:solidFill>
-          <a:prstDash val="solid"/>
-        </a:ln>
-        <a:ln w="25400" cap="flat" cmpd="sng" algn="ctr">
           <a:solidFill>
             <a:schemeClr val="phClr"/>
           </a:solidFill>
           <a:prstDash val="solid"/>
         </a:ln>
-        <a:ln w="38100" cap="flat" cmpd="sng" algn="ctr">
+        <a:ln w="10795" cap="flat" cmpd="sng" algn="ctr">
           <a:solidFill>
             <a:schemeClr val="phClr"/>
+          </a:solidFill>
+          <a:prstDash val="solid"/>
+        </a:ln>
+        <a:ln w="17145" cap="flat" cmpd="sng" algn="ctr">
+          <a:solidFill>
+            <a:schemeClr val="phClr">
+              <a:shade val="95000"/>
+              <a:alpha val="50000"/>
+              <a:satMod val="150000"/>
+            </a:schemeClr>
           </a:solidFill>
           <a:prstDash val="solid"/>
         </a:ln>
       </a:lnStyleLst>
       <a:effectStyleLst>
         <a:effectStyle>
-          <a:effectLst>
-            <a:outerShdw blurRad="40000" dist="20000" dir="5400000" rotWithShape="0">
-              <a:srgbClr val="000000">
-                <a:alpha val="38000"/>
-              </a:srgbClr>
-            </a:outerShdw>
-          </a:effectLst>
+          <a:effectLst/>
+        </a:effectStyle>
+        <a:effectStyle>
+          <a:effectLst/>
         </a:effectStyle>
         <a:effectStyle>
           <a:effectLst>
-            <a:outerShdw blurRad="40000" dist="23000" dir="5400000" rotWithShape="0">
+            <a:outerShdw blurRad="44450" dist="13970" dir="5400000" algn="ctr" rotWithShape="0">
               <a:srgbClr val="000000">
-                <a:alpha val="35000"/>
-              </a:srgbClr>
-            </a:outerShdw>
-          </a:effectLst>
-        </a:effectStyle>
-        <a:effectStyle>
-          <a:effectLst>
-            <a:outerShdw blurRad="40000" dist="23000" dir="5400000" rotWithShape="0">
-              <a:srgbClr val="000000">
-                <a:alpha val="35000"/>
+                <a:alpha val="45000"/>
               </a:srgbClr>
             </a:outerShdw>
           </a:effectLst>
@@ -5373,12 +5845,10 @@
             <a:camera prst="orthographicFront">
               <a:rot lat="0" lon="0" rev="0"/>
             </a:camera>
-            <a:lightRig rig="threePt" dir="t">
-              <a:rot lat="0" lon="0" rev="1200000"/>
-            </a:lightRig>
+            <a:lightRig rig="twoPt" dir="tl"/>
           </a:scene3d>
-          <a:sp3d>
-            <a:bevelT w="63500" h="25400"/>
+          <a:sp3d prstMaterial="flat">
+            <a:bevelT w="19050" h="31750" prst="coolSlant"/>
           </a:sp3d>
         </a:effectStyle>
       </a:effectStyleLst>
@@ -5390,90 +5860,37 @@
           <a:gsLst>
             <a:gs pos="0">
               <a:schemeClr val="phClr">
-                <a:tint val="40000"/>
-                <a:satMod val="350000"/>
-              </a:schemeClr>
-            </a:gs>
-            <a:gs pos="40000">
-              <a:schemeClr val="phClr">
-                <a:tint val="45000"/>
-                <a:shade val="99000"/>
-                <a:satMod val="350000"/>
+                <a:tint val="70000"/>
               </a:schemeClr>
             </a:gs>
             <a:gs pos="100000">
               <a:schemeClr val="phClr">
-                <a:shade val="20000"/>
-                <a:satMod val="255000"/>
+                <a:shade val="80000"/>
               </a:schemeClr>
             </a:gs>
           </a:gsLst>
           <a:path path="circle">
-            <a:fillToRect l="50000" t="-80000" r="50000" b="180000"/>
+            <a:fillToRect l="50000" t="100000" r="100000" b="100000"/>
           </a:path>
         </a:gradFill>
-        <a:gradFill rotWithShape="1">
-          <a:gsLst>
-            <a:gs pos="0">
-              <a:schemeClr val="phClr">
-                <a:tint val="80000"/>
-                <a:satMod val="300000"/>
-              </a:schemeClr>
-            </a:gs>
-            <a:gs pos="100000">
+        <a:blipFill rotWithShape="1">
+          <a:blip xmlns:r="http://schemas.openxmlformats.org/officeDocument/2006/relationships" r:embed="rId1">
+            <a:duotone>
               <a:schemeClr val="phClr">
                 <a:shade val="30000"/>
                 <a:satMod val="200000"/>
               </a:schemeClr>
-            </a:gs>
-          </a:gsLst>
-          <a:path path="circle">
-            <a:fillToRect l="50000" t="50000" r="50000" b="50000"/>
-          </a:path>
-        </a:gradFill>
+              <a:schemeClr val="phClr">
+                <a:tint val="20000"/>
+              </a:schemeClr>
+            </a:duotone>
+          </a:blip>
+          <a:stretch/>
+        </a:blipFill>
       </a:bgFillStyleLst>
     </a:fmtScheme>
   </a:themeElements>
-  <a:objectDefaults>
-    <a:spDef>
-      <a:spPr/>
-      <a:bodyPr/>
-      <a:lstStyle/>
-      <a:style>
-        <a:lnRef idx="1">
-          <a:schemeClr val="accent1"/>
-        </a:lnRef>
-        <a:fillRef idx="3">
-          <a:schemeClr val="accent1"/>
-        </a:fillRef>
-        <a:effectRef idx="2">
-          <a:schemeClr val="accent1"/>
-        </a:effectRef>
-        <a:fontRef idx="minor">
-          <a:schemeClr val="lt1"/>
-        </a:fontRef>
-      </a:style>
-    </a:spDef>
-    <a:lnDef>
-      <a:spPr/>
-      <a:bodyPr/>
-      <a:lstStyle/>
-      <a:style>
-        <a:lnRef idx="2">
-          <a:schemeClr val="accent1"/>
-        </a:lnRef>
-        <a:fillRef idx="0">
-          <a:schemeClr val="accent1"/>
-        </a:fillRef>
-        <a:effectRef idx="1">
-          <a:schemeClr val="accent1"/>
-        </a:effectRef>
-        <a:fontRef idx="minor">
-          <a:schemeClr val="tx1"/>
-        </a:fontRef>
-      </a:style>
-    </a:lnDef>
-  </a:objectDefaults>
+  <a:objectDefaults/>
   <a:extraClrSchemeLst/>
 </a:theme>
 </file>
</xml_diff>